<commit_message>
Made updates to queries.sql
</commit_message>
<xml_diff>
--- a/Weather Analytics Platform.pptx
+++ b/Weather Analytics Platform.pptx
@@ -262,7 +262,7 @@
           <a:p>
             <a:fld id="{F13668CF-2E7A-6240-A960-32F6D772A300}" type="datetimeFigureOut">
               <a:rPr lang="en-US" smtClean="0"/>
-              <a:t>7/9/26</a:t>
+              <a:t>7/10/26</a:t>
             </a:fld>
             <a:endParaRPr lang="en-US"/>
           </a:p>
@@ -460,7 +460,7 @@
           <a:p>
             <a:fld id="{F13668CF-2E7A-6240-A960-32F6D772A300}" type="datetimeFigureOut">
               <a:rPr lang="en-US" smtClean="0"/>
-              <a:t>7/9/26</a:t>
+              <a:t>7/10/26</a:t>
             </a:fld>
             <a:endParaRPr lang="en-US"/>
           </a:p>
@@ -668,7 +668,7 @@
           <a:p>
             <a:fld id="{F13668CF-2E7A-6240-A960-32F6D772A300}" type="datetimeFigureOut">
               <a:rPr lang="en-US" smtClean="0"/>
-              <a:t>7/9/26</a:t>
+              <a:t>7/10/26</a:t>
             </a:fld>
             <a:endParaRPr lang="en-US"/>
           </a:p>
@@ -866,7 +866,7 @@
           <a:p>
             <a:fld id="{F13668CF-2E7A-6240-A960-32F6D772A300}" type="datetimeFigureOut">
               <a:rPr lang="en-US" smtClean="0"/>
-              <a:t>7/9/26</a:t>
+              <a:t>7/10/26</a:t>
             </a:fld>
             <a:endParaRPr lang="en-US"/>
           </a:p>
@@ -1141,7 +1141,7 @@
           <a:p>
             <a:fld id="{F13668CF-2E7A-6240-A960-32F6D772A300}" type="datetimeFigureOut">
               <a:rPr lang="en-US" smtClean="0"/>
-              <a:t>7/9/26</a:t>
+              <a:t>7/10/26</a:t>
             </a:fld>
             <a:endParaRPr lang="en-US"/>
           </a:p>
@@ -1406,7 +1406,7 @@
           <a:p>
             <a:fld id="{F13668CF-2E7A-6240-A960-32F6D772A300}" type="datetimeFigureOut">
               <a:rPr lang="en-US" smtClean="0"/>
-              <a:t>7/9/26</a:t>
+              <a:t>7/10/26</a:t>
             </a:fld>
             <a:endParaRPr lang="en-US"/>
           </a:p>
@@ -1818,7 +1818,7 @@
           <a:p>
             <a:fld id="{F13668CF-2E7A-6240-A960-32F6D772A300}" type="datetimeFigureOut">
               <a:rPr lang="en-US" smtClean="0"/>
-              <a:t>7/9/26</a:t>
+              <a:t>7/10/26</a:t>
             </a:fld>
             <a:endParaRPr lang="en-US"/>
           </a:p>
@@ -1959,7 +1959,7 @@
           <a:p>
             <a:fld id="{F13668CF-2E7A-6240-A960-32F6D772A300}" type="datetimeFigureOut">
               <a:rPr lang="en-US" smtClean="0"/>
-              <a:t>7/9/26</a:t>
+              <a:t>7/10/26</a:t>
             </a:fld>
             <a:endParaRPr lang="en-US"/>
           </a:p>
@@ -2072,7 +2072,7 @@
           <a:p>
             <a:fld id="{F13668CF-2E7A-6240-A960-32F6D772A300}" type="datetimeFigureOut">
               <a:rPr lang="en-US" smtClean="0"/>
-              <a:t>7/9/26</a:t>
+              <a:t>7/10/26</a:t>
             </a:fld>
             <a:endParaRPr lang="en-US"/>
           </a:p>
@@ -2383,7 +2383,7 @@
           <a:p>
             <a:fld id="{F13668CF-2E7A-6240-A960-32F6D772A300}" type="datetimeFigureOut">
               <a:rPr lang="en-US" smtClean="0"/>
-              <a:t>7/9/26</a:t>
+              <a:t>7/10/26</a:t>
             </a:fld>
             <a:endParaRPr lang="en-US"/>
           </a:p>
@@ -2671,7 +2671,7 @@
           <a:p>
             <a:fld id="{F13668CF-2E7A-6240-A960-32F6D772A300}" type="datetimeFigureOut">
               <a:rPr lang="en-US" smtClean="0"/>
-              <a:t>7/9/26</a:t>
+              <a:t>7/10/26</a:t>
             </a:fld>
             <a:endParaRPr lang="en-US"/>
           </a:p>
@@ -2912,7 +2912,7 @@
           <a:p>
             <a:fld id="{F13668CF-2E7A-6240-A960-32F6D772A300}" type="datetimeFigureOut">
               <a:rPr lang="en-US" smtClean="0"/>
-              <a:t>7/9/26</a:t>
+              <a:t>7/10/26</a:t>
             </a:fld>
             <a:endParaRPr lang="en-US"/>
           </a:p>
@@ -3377,7 +3377,7 @@
         </p:nvSpPr>
         <p:spPr>
           <a:xfrm>
-            <a:off x="2615611" y="2957050"/>
+            <a:off x="3085874" y="3429000"/>
             <a:ext cx="7389628" cy="1411731"/>
           </a:xfrm>
         </p:spPr>
@@ -3620,7 +3620,7 @@
         <p:spPr>
           <a:xfrm>
             <a:off x="123570" y="665917"/>
-            <a:ext cx="11763630" cy="1015663"/>
+            <a:ext cx="11763630" cy="1246495"/>
           </a:xfrm>
           <a:prstGeom prst="rect">
             <a:avLst/>
@@ -3640,7 +3640,7 @@
               <a:rPr lang="en-US" sz="1500" dirty="0">
                 <a:latin typeface="Avenir Book" panose="02000503020000020003" pitchFamily="2" charset="0"/>
               </a:rPr>
-              <a:t>Weather Analysis Platform is an application that imports weather data from an open source weather service: Open Mateo API weather.  Raw data is stored in JSON format located in Data/Raw directory.  From there, the raw is imported to data frame to conduct data wrangling operation.  During this phase, data wrangling operations include removal of duplicates, filling null values, eliminating negative values, and addressing data inconsistencies (example: min &gt; max).</a:t>
+              <a:t>Weather Analysis Platform is an application that analyzes the temperatures of Berkeley, Oakland and San Francisco.  It operates by importing weather data from an opensource weather service: Open Mateo API weather.  Raw data is stored in JSON format located in Data/Raw directory.  From there, the raw is imported to data frame to conduct data wrangling operation.  During this phase, data wrangling operations include removal of duplicates, filling null values, eliminating negative values, and addressing data inconsistencies (example: min &gt; max).</a:t>
             </a:r>
           </a:p>
         </p:txBody>
@@ -4106,7 +4106,7 @@
         </p:nvSpPr>
         <p:spPr>
           <a:xfrm>
-            <a:off x="123570" y="769441"/>
+            <a:off x="123570" y="701870"/>
             <a:ext cx="11763630" cy="1015663"/>
           </a:xfrm>
           <a:prstGeom prst="rect">
@@ -4125,9 +4125,10 @@
           <a:p>
             <a:r>
               <a:rPr lang="en-US" sz="1500" dirty="0">
-                <a:latin typeface="Avenir Book" panose="02000503020000020003" pitchFamily="2" charset="0"/>
-              </a:rPr>
-              <a:t>Weather Analysis Platform is an application that imports weather data from an opensource weather service: Open Mateo API weather.  Raw data is stored in JSON format located in /Raw directory.  From there, the raw is imported to data frame to conduct data wrangling operation.  During this phase, data wrangling operations include removal of duplicates, filling null values, eliminating negative values, and addressing data inconsistencies (example: min &gt; max).</a:t>
+                <a:latin typeface="Baloo 2" panose="03080502040302020200" pitchFamily="66" charset="77"/>
+                <a:cs typeface="Baloo 2" panose="03080502040302020200" pitchFamily="66" charset="77"/>
+              </a:rPr>
+              <a:t>Weather Analysis Platform is an application that imports weather data from an opensource weather service: Open Mateo API weather.  Raw data is stored in JSON format located in /Raw directory.  From there, the raw is imported to data frame to conduct data wrangling operation.  During this phase, data wrangling operations include removal of duplicates, filling null values, eliminating negative values, and addressing data inconsistencies (example: min &gt; max).  From there, data is configured </a:t>
             </a:r>
           </a:p>
         </p:txBody>
@@ -4210,14 +4211,14 @@
           <p:nvPr>
             <p:extLst>
               <p:ext uri="{D42A27DB-BD31-4B8C-83A1-F6EECF244321}">
-                <p14:modId xmlns:p14="http://schemas.microsoft.com/office/powerpoint/2010/main" val="2035346703"/>
+                <p14:modId xmlns:p14="http://schemas.microsoft.com/office/powerpoint/2010/main" val="1615813607"/>
               </p:ext>
             </p:extLst>
           </p:nvPr>
         </p:nvGraphicFramePr>
         <p:xfrm>
           <a:off x="2007446" y="2032298"/>
-          <a:ext cx="7902451" cy="3725730"/>
+          <a:ext cx="7902451" cy="4396290"/>
         </p:xfrm>
         <a:graphic>
           <a:graphicData uri="http://schemas.openxmlformats.org/drawingml/2006/table">
@@ -4260,7 +4261,11 @@
                     </a:p>
                   </a:txBody>
                   <a:tcPr>
-                    <a:noFill/>
+                    <a:solidFill>
+                      <a:schemeClr val="bg1">
+                        <a:alpha val="41008"/>
+                      </a:schemeClr>
+                    </a:solidFill>
                   </a:tcPr>
                 </a:tc>
                 <a:tc>
@@ -4281,7 +4286,11 @@
                     </a:p>
                   </a:txBody>
                   <a:tcPr>
-                    <a:noFill/>
+                    <a:solidFill>
+                      <a:schemeClr val="bg1">
+                        <a:alpha val="41008"/>
+                      </a:schemeClr>
+                    </a:solidFill>
                   </a:tcPr>
                 </a:tc>
                 <a:extLst>
@@ -4310,7 +4319,7 @@
                   <a:tcPr>
                     <a:solidFill>
                       <a:schemeClr val="bg1">
-                        <a:alpha val="25112"/>
+                        <a:alpha val="53831"/>
                       </a:schemeClr>
                     </a:solidFill>
                   </a:tcPr>
@@ -4331,7 +4340,7 @@
                   <a:tcPr>
                     <a:solidFill>
                       <a:schemeClr val="bg1">
-                        <a:alpha val="25112"/>
+                        <a:alpha val="53918"/>
                       </a:schemeClr>
                     </a:solidFill>
                   </a:tcPr>
@@ -4379,7 +4388,7 @@
                   <a:tcPr>
                     <a:solidFill>
                       <a:schemeClr val="bg1">
-                        <a:alpha val="25112"/>
+                        <a:alpha val="53831"/>
                       </a:schemeClr>
                     </a:solidFill>
                   </a:tcPr>
@@ -4426,7 +4435,7 @@
                   <a:tcPr>
                     <a:solidFill>
                       <a:schemeClr val="bg1">
-                        <a:alpha val="25112"/>
+                        <a:alpha val="53918"/>
                       </a:schemeClr>
                     </a:solidFill>
                   </a:tcPr>
@@ -4474,7 +4483,7 @@
                   <a:tcPr>
                     <a:solidFill>
                       <a:schemeClr val="bg1">
-                        <a:alpha val="25112"/>
+                        <a:alpha val="53831"/>
                       </a:schemeClr>
                     </a:solidFill>
                   </a:tcPr>
@@ -4540,7 +4549,7 @@
                   <a:tcPr>
                     <a:solidFill>
                       <a:schemeClr val="bg1">
-                        <a:alpha val="25112"/>
+                        <a:alpha val="53918"/>
                       </a:schemeClr>
                     </a:solidFill>
                   </a:tcPr>
@@ -4591,7 +4600,7 @@
                   <a:tcPr>
                     <a:solidFill>
                       <a:schemeClr val="bg1">
-                        <a:alpha val="25112"/>
+                        <a:alpha val="53831"/>
                       </a:schemeClr>
                     </a:solidFill>
                   </a:tcPr>
@@ -4602,15 +4611,21 @@
                     <a:lstStyle/>
                     <a:p>
                       <a:r>
-                        <a:rPr lang="en-US" sz="1100" dirty="0"/>
+                        <a:rPr lang="en-US" sz="1100" dirty="0">
+                          <a:latin typeface="Avenir Book" panose="02000503020000020003" pitchFamily="2" charset="0"/>
+                        </a:rPr>
                         <a:t>Exports </a:t>
                       </a:r>
                       <a:r>
-                        <a:rPr lang="en-US" sz="1100" dirty="0" err="1"/>
+                        <a:rPr lang="en-US" sz="1100" dirty="0" err="1">
+                          <a:latin typeface="Avenir Book" panose="02000503020000020003" pitchFamily="2" charset="0"/>
+                        </a:rPr>
                         <a:t>weather.csv</a:t>
                       </a:r>
                       <a:r>
-                        <a:rPr lang="en-US" sz="1100" dirty="0"/>
+                        <a:rPr lang="en-US" sz="1100" dirty="0">
+                          <a:latin typeface="Avenir Book" panose="02000503020000020003" pitchFamily="2" charset="0"/>
+                        </a:rPr>
                         <a:t> into Postgres and inserts data frame information into its corresponding tables</a:t>
                       </a:r>
                     </a:p>
@@ -4618,7 +4633,7 @@
                   <a:tcPr>
                     <a:solidFill>
                       <a:schemeClr val="bg1">
-                        <a:alpha val="25112"/>
+                        <a:alpha val="53918"/>
                       </a:schemeClr>
                     </a:solidFill>
                   </a:tcPr>
@@ -4669,7 +4684,7 @@
                   <a:tcPr>
                     <a:solidFill>
                       <a:schemeClr val="bg1">
-                        <a:alpha val="25112"/>
+                        <a:alpha val="53831"/>
                       </a:schemeClr>
                     </a:solidFill>
                   </a:tcPr>
@@ -4680,7 +4695,9 @@
                     <a:lstStyle/>
                     <a:p>
                       <a:r>
-                        <a:rPr lang="en-US" sz="1100" dirty="0"/>
+                        <a:rPr lang="en-US" sz="1100" dirty="0">
+                          <a:latin typeface="Avenir Book" panose="02000503020000020003" pitchFamily="2" charset="0"/>
+                        </a:rPr>
                         <a:t>Calls schema file</a:t>
                       </a:r>
                     </a:p>
@@ -4688,7 +4705,7 @@
                   <a:tcPr>
                     <a:solidFill>
                       <a:schemeClr val="bg1">
-                        <a:alpha val="25112"/>
+                        <a:alpha val="53918"/>
                       </a:schemeClr>
                     </a:solidFill>
                   </a:tcPr>
@@ -4739,7 +4756,7 @@
                   <a:tcPr>
                     <a:solidFill>
                       <a:schemeClr val="bg1">
-                        <a:alpha val="25839"/>
+                        <a:alpha val="53831"/>
                       </a:schemeClr>
                     </a:solidFill>
                   </a:tcPr>
@@ -4750,7 +4767,9 @@
                     <a:lstStyle/>
                     <a:p>
                       <a:r>
-                        <a:rPr lang="en-US" sz="1100" dirty="0"/>
+                        <a:rPr lang="en-US" sz="1100" dirty="0">
+                          <a:latin typeface="Avenir Book" panose="02000503020000020003" pitchFamily="2" charset="0"/>
+                        </a:rPr>
                         <a:t>Creates cities and weather table using DDL logic</a:t>
                       </a:r>
                     </a:p>
@@ -4758,7 +4777,7 @@
                   <a:tcPr>
                     <a:solidFill>
                       <a:schemeClr val="bg1">
-                        <a:alpha val="25839"/>
+                        <a:alpha val="53722"/>
                       </a:schemeClr>
                     </a:solidFill>
                   </a:tcPr>
@@ -4809,7 +4828,7 @@
                   <a:tcPr>
                     <a:solidFill>
                       <a:schemeClr val="bg1">
-                        <a:alpha val="26000"/>
+                        <a:alpha val="53922"/>
                       </a:schemeClr>
                     </a:solidFill>
                   </a:tcPr>
@@ -4820,15 +4839,57 @@
                     <a:lstStyle/>
                     <a:p>
                       <a:r>
-                        <a:rPr lang="en-US" sz="1100" dirty="0"/>
-                        <a:t>Produces 5 queries: hottest day of year per city, average rainfall, monthly precipitation, determine peak wind per week for each city, frequency of extreme heat days over 86 degree Fahrenheit.  </a:t>
+                        <a:rPr lang="en-US" sz="1100" dirty="0">
+                          <a:latin typeface="Avenir Book" panose="02000503020000020003" pitchFamily="2" charset="0"/>
+                        </a:rPr>
+                        <a:t>Produces 5 queries:  </a:t>
+                      </a:r>
+                    </a:p>
+                    <a:p>
+                      <a:r>
+                        <a:rPr lang="en-US" sz="1100" dirty="0">
+                          <a:latin typeface="Avenir Book" panose="02000503020000020003" pitchFamily="2" charset="0"/>
+                        </a:rPr>
+                        <a:t>• Hottest day of year per city</a:t>
+                      </a:r>
+                    </a:p>
+                    <a:p>
+                      <a:r>
+                        <a:rPr lang="en-US" sz="1100" dirty="0">
+                          <a:latin typeface="Avenir Book" panose="02000503020000020003" pitchFamily="2" charset="0"/>
+                        </a:rPr>
+                        <a:t>• Average rainfall</a:t>
+                      </a:r>
+                    </a:p>
+                    <a:p>
+                      <a:r>
+                        <a:rPr lang="en-US" sz="1100" dirty="0">
+                          <a:latin typeface="Avenir Book" panose="02000503020000020003" pitchFamily="2" charset="0"/>
+                        </a:rPr>
+                        <a:t>• Monthly precipitation</a:t>
+                      </a:r>
+                    </a:p>
+                    <a:p>
+                      <a:r>
+                        <a:rPr lang="en-US" sz="1100" dirty="0">
+                          <a:latin typeface="Avenir Book" panose="02000503020000020003" pitchFamily="2" charset="0"/>
+                        </a:rPr>
+                        <a:t>• Determine peak wind per week for each city</a:t>
+                      </a:r>
+                    </a:p>
+                    <a:p>
+                      <a:r>
+                        <a:rPr lang="en-US" sz="1100" dirty="0">
+                          <a:latin typeface="Avenir Book" panose="02000503020000020003" pitchFamily="2" charset="0"/>
+                        </a:rPr>
+                        <a:t>• Frequency of extreme heat days over 86 degree Fahrenheit </a:t>
                       </a:r>
                     </a:p>
                   </a:txBody>
                   <a:tcPr>
                     <a:solidFill>
                       <a:schemeClr val="bg1">
-                        <a:alpha val="26000"/>
+                        <a:alpha val="54332"/>
                       </a:schemeClr>
                     </a:solidFill>
                   </a:tcPr>
@@ -5022,10 +5083,134 @@
       </p:sp>
       <p:sp>
         <p:nvSpPr>
-          <p:cNvPr id="19" name="Rectangle 18">
-            <a:extLst>
-              <a:ext uri="{FF2B5EF4-FFF2-40B4-BE49-F238E27FC236}">
-                <a16:creationId xmlns:a16="http://schemas.microsoft.com/office/drawing/2014/main" id="{FD9894AC-97B6-ADE4-C6F9-12EEBD68A5D0}"/>
+          <p:cNvPr id="5" name="TextBox 4">
+            <a:extLst>
+              <a:ext uri="{FF2B5EF4-FFF2-40B4-BE49-F238E27FC236}">
+                <a16:creationId xmlns:a16="http://schemas.microsoft.com/office/drawing/2014/main" id="{2CEE8899-D776-1DBB-5792-EFAC7D7FF593}"/>
+              </a:ext>
+            </a:extLst>
+          </p:cNvPr>
+          <p:cNvSpPr txBox="1"/>
+          <p:nvPr/>
+        </p:nvSpPr>
+        <p:spPr>
+          <a:xfrm>
+            <a:off x="123570" y="733342"/>
+            <a:ext cx="10909300" cy="1384995"/>
+          </a:xfrm>
+          <a:prstGeom prst="rect">
+            <a:avLst/>
+          </a:prstGeom>
+          <a:noFill/>
+        </p:spPr>
+        <p:txBody>
+          <a:bodyPr wrap="square">
+            <a:spAutoFit/>
+          </a:bodyPr>
+          <a:lstStyle/>
+          <a:p>
+            <a:pPr marL="0" marR="0">
+              <a:buNone/>
+            </a:pPr>
+            <a:r>
+              <a:rPr lang="en-US" sz="1200" dirty="0">
+                <a:effectLst/>
+                <a:latin typeface="Avenir Book" panose="02000503020000020003" pitchFamily="2" charset="0"/>
+              </a:rPr>
+              <a:t>Five SQL queries in `</a:t>
+            </a:r>
+            <a:r>
+              <a:rPr lang="en-US" sz="1200" dirty="0" err="1">
+                <a:effectLst/>
+                <a:latin typeface="Avenir Book" panose="02000503020000020003" pitchFamily="2" charset="0"/>
+              </a:rPr>
+              <a:t>queries.sql</a:t>
+            </a:r>
+            <a:r>
+              <a:rPr lang="en-US" sz="1200" dirty="0">
+                <a:effectLst/>
+                <a:latin typeface="Avenir Book" panose="02000503020000020003" pitchFamily="2" charset="0"/>
+              </a:rPr>
+              <a:t>` perform operations such as:</a:t>
+            </a:r>
+          </a:p>
+          <a:p>
+            <a:pPr marL="0" marR="0">
+              <a:buNone/>
+            </a:pPr>
+            <a:endParaRPr lang="en-US" sz="1200" dirty="0">
+              <a:effectLst/>
+              <a:latin typeface="Avenir Book" panose="02000503020000020003" pitchFamily="2" charset="0"/>
+            </a:endParaRPr>
+          </a:p>
+          <a:p>
+            <a:pPr marL="0" marR="0">
+              <a:buNone/>
+            </a:pPr>
+            <a:r>
+              <a:rPr lang="en-US" sz="1200" dirty="0">
+                <a:effectLst/>
+                <a:latin typeface="Avenir Book" panose="02000503020000020003" pitchFamily="2" charset="0"/>
+              </a:rPr>
+              <a:t>• Hottest day of the year per city</a:t>
+            </a:r>
+          </a:p>
+          <a:p>
+            <a:pPr marL="0" marR="0">
+              <a:buNone/>
+            </a:pPr>
+            <a:r>
+              <a:rPr lang="en-US" sz="1200" dirty="0">
+                <a:effectLst/>
+                <a:latin typeface="Avenir Book" panose="02000503020000020003" pitchFamily="2" charset="0"/>
+              </a:rPr>
+              <a:t>• Average rainfall, </a:t>
+            </a:r>
+          </a:p>
+          <a:p>
+            <a:pPr marL="0" marR="0">
+              <a:buNone/>
+            </a:pPr>
+            <a:r>
+              <a:rPr lang="en-US" sz="1200" dirty="0">
+                <a:effectLst/>
+                <a:latin typeface="Avenir Book" panose="02000503020000020003" pitchFamily="2" charset="0"/>
+              </a:rPr>
+              <a:t>• Monthly precipitation, </a:t>
+            </a:r>
+          </a:p>
+          <a:p>
+            <a:pPr marL="0" marR="0">
+              <a:buNone/>
+            </a:pPr>
+            <a:r>
+              <a:rPr lang="en-US" sz="1200" dirty="0">
+                <a:effectLst/>
+                <a:latin typeface="Avenir Book" panose="02000503020000020003" pitchFamily="2" charset="0"/>
+              </a:rPr>
+              <a:t>• Windiest weeks,</a:t>
+            </a:r>
+          </a:p>
+          <a:p>
+            <a:pPr marL="0" marR="0">
+              <a:buNone/>
+            </a:pPr>
+            <a:r>
+              <a:rPr lang="en-US" sz="1200" dirty="0">
+                <a:effectLst/>
+                <a:latin typeface="Avenir Book" panose="02000503020000020003" pitchFamily="2" charset="0"/>
+              </a:rPr>
+              <a:t>• Frequency of extreme heat days over 88 degree Fahrenheit.</a:t>
+            </a:r>
+          </a:p>
+        </p:txBody>
+      </p:sp>
+      <p:sp>
+        <p:nvSpPr>
+          <p:cNvPr id="4" name="Rectangle 3">
+            <a:extLst>
+              <a:ext uri="{FF2B5EF4-FFF2-40B4-BE49-F238E27FC236}">
+                <a16:creationId xmlns:a16="http://schemas.microsoft.com/office/drawing/2014/main" id="{E16EDCD1-0A13-FE1B-921F-38FA27FAD6B2}"/>
               </a:ext>
             </a:extLst>
           </p:cNvPr>
@@ -5034,15 +5219,15 @@
         </p:nvSpPr>
         <p:spPr>
           <a:xfrm>
-            <a:off x="61785" y="733341"/>
-            <a:ext cx="12006645" cy="5484937"/>
+            <a:off x="78378" y="2201247"/>
+            <a:ext cx="11993526" cy="4017031"/>
           </a:xfrm>
           <a:prstGeom prst="rect">
             <a:avLst/>
           </a:prstGeom>
           <a:solidFill>
             <a:schemeClr val="bg1">
-              <a:alpha val="28663"/>
+              <a:alpha val="61595"/>
             </a:schemeClr>
           </a:solidFill>
           <a:ln>
@@ -5076,10 +5261,10 @@
       </p:sp>
       <p:sp>
         <p:nvSpPr>
-          <p:cNvPr id="5" name="TextBox 4">
-            <a:extLst>
-              <a:ext uri="{FF2B5EF4-FFF2-40B4-BE49-F238E27FC236}">
-                <a16:creationId xmlns:a16="http://schemas.microsoft.com/office/drawing/2014/main" id="{2CEE8899-D776-1DBB-5792-EFAC7D7FF593}"/>
+          <p:cNvPr id="7" name="TextBox 6">
+            <a:extLst>
+              <a:ext uri="{FF2B5EF4-FFF2-40B4-BE49-F238E27FC236}">
+                <a16:creationId xmlns:a16="http://schemas.microsoft.com/office/drawing/2014/main" id="{890F4F83-4963-FB85-6D5C-99F2767D49A3}"/>
               </a:ext>
             </a:extLst>
           </p:cNvPr>
@@ -5088,8 +5273,8 @@
         </p:nvSpPr>
         <p:spPr>
           <a:xfrm>
-            <a:off x="123570" y="733342"/>
-            <a:ext cx="10909300" cy="1384995"/>
+            <a:off x="120096" y="1948519"/>
+            <a:ext cx="10376263" cy="4830618"/>
           </a:xfrm>
           <a:prstGeom prst="rect">
             <a:avLst/>
@@ -5102,130 +5287,6 @@
           </a:bodyPr>
           <a:lstStyle/>
           <a:p>
-            <a:pPr marL="0" marR="0">
-              <a:buNone/>
-            </a:pPr>
-            <a:r>
-              <a:rPr lang="en-US" sz="1200" dirty="0">
-                <a:effectLst/>
-                <a:latin typeface="Menlo" panose="020B0609030804020204" pitchFamily="49" charset="0"/>
-              </a:rPr>
-              <a:t>Five SQL queries in `</a:t>
-            </a:r>
-            <a:r>
-              <a:rPr lang="en-US" sz="1200" dirty="0" err="1">
-                <a:effectLst/>
-                <a:latin typeface="Menlo" panose="020B0609030804020204" pitchFamily="49" charset="0"/>
-              </a:rPr>
-              <a:t>queries.sql</a:t>
-            </a:r>
-            <a:r>
-              <a:rPr lang="en-US" sz="1200" dirty="0">
-                <a:effectLst/>
-                <a:latin typeface="Menlo" panose="020B0609030804020204" pitchFamily="49" charset="0"/>
-              </a:rPr>
-              <a:t>` perform operations such as:</a:t>
-            </a:r>
-          </a:p>
-          <a:p>
-            <a:pPr marL="0" marR="0">
-              <a:buNone/>
-            </a:pPr>
-            <a:endParaRPr lang="en-US" sz="1200" dirty="0">
-              <a:effectLst/>
-              <a:latin typeface="Menlo" panose="020B0609030804020204" pitchFamily="49" charset="0"/>
-            </a:endParaRPr>
-          </a:p>
-          <a:p>
-            <a:pPr marL="0" marR="0">
-              <a:buNone/>
-            </a:pPr>
-            <a:r>
-              <a:rPr lang="en-US" sz="1200" dirty="0">
-                <a:effectLst/>
-                <a:latin typeface="Menlo" panose="020B0609030804020204" pitchFamily="49" charset="0"/>
-              </a:rPr>
-              <a:t>• Hottest day of the year per city</a:t>
-            </a:r>
-          </a:p>
-          <a:p>
-            <a:pPr marL="0" marR="0">
-              <a:buNone/>
-            </a:pPr>
-            <a:r>
-              <a:rPr lang="en-US" sz="1200" dirty="0">
-                <a:effectLst/>
-                <a:latin typeface="Menlo" panose="020B0609030804020204" pitchFamily="49" charset="0"/>
-              </a:rPr>
-              <a:t>• Average rainfall, </a:t>
-            </a:r>
-          </a:p>
-          <a:p>
-            <a:pPr marL="0" marR="0">
-              <a:buNone/>
-            </a:pPr>
-            <a:r>
-              <a:rPr lang="en-US" sz="1200" dirty="0">
-                <a:effectLst/>
-                <a:latin typeface="Menlo" panose="020B0609030804020204" pitchFamily="49" charset="0"/>
-              </a:rPr>
-              <a:t>• Monthly precipitation, </a:t>
-            </a:r>
-          </a:p>
-          <a:p>
-            <a:pPr marL="0" marR="0">
-              <a:buNone/>
-            </a:pPr>
-            <a:r>
-              <a:rPr lang="en-US" sz="1200" dirty="0">
-                <a:effectLst/>
-                <a:latin typeface="Menlo" panose="020B0609030804020204" pitchFamily="49" charset="0"/>
-              </a:rPr>
-              <a:t>• Windiest weeks,</a:t>
-            </a:r>
-          </a:p>
-          <a:p>
-            <a:pPr marL="0" marR="0">
-              <a:buNone/>
-            </a:pPr>
-            <a:r>
-              <a:rPr lang="en-US" sz="1200" dirty="0">
-                <a:effectLst/>
-                <a:latin typeface="Menlo" panose="020B0609030804020204" pitchFamily="49" charset="0"/>
-              </a:rPr>
-              <a:t>• Frequency of extreme heat days over 88 degree Fahrenheit.</a:t>
-            </a:r>
-          </a:p>
-        </p:txBody>
-      </p:sp>
-      <p:sp>
-        <p:nvSpPr>
-          <p:cNvPr id="7" name="TextBox 6">
-            <a:extLst>
-              <a:ext uri="{FF2B5EF4-FFF2-40B4-BE49-F238E27FC236}">
-                <a16:creationId xmlns:a16="http://schemas.microsoft.com/office/drawing/2014/main" id="{890F4F83-4963-FB85-6D5C-99F2767D49A3}"/>
-              </a:ext>
-            </a:extLst>
-          </p:cNvPr>
-          <p:cNvSpPr txBox="1"/>
-          <p:nvPr/>
-        </p:nvSpPr>
-        <p:spPr>
-          <a:xfrm>
-            <a:off x="123570" y="1955406"/>
-            <a:ext cx="12068430" cy="4743414"/>
-          </a:xfrm>
-          <a:prstGeom prst="rect">
-            <a:avLst/>
-          </a:prstGeom>
-          <a:noFill/>
-        </p:spPr>
-        <p:txBody>
-          <a:bodyPr wrap="square">
-            <a:spAutoFit/>
-          </a:bodyPr>
-          <a:lstStyle/>
-          <a:p>
             <a:pPr>
               <a:lnSpc>
                 <a:spcPts val="1350"/>
@@ -5262,219 +5323,196 @@
             </a:r>
           </a:p>
           <a:p>
-            <a:pPr>
-              <a:lnSpc>
-                <a:spcPts val="1350"/>
-              </a:lnSpc>
-              <a:buNone/>
-            </a:pPr>
-            <a:r>
-              <a:rPr lang="en-US" sz="900" b="0" dirty="0">
-                <a:effectLst/>
-                <a:latin typeface="Menlo" panose="020B0609030804020204" pitchFamily="49" charset="0"/>
+            <a:r>
+              <a:rPr lang="en-US" sz="1000" dirty="0">
+                <a:latin typeface="Avenir Book" panose="02000503020000020003" pitchFamily="2" charset="0"/>
               </a:rPr>
               <a:t>SELECT DISTINCT ON (</a:t>
             </a:r>
             <a:r>
-              <a:rPr lang="en-US" sz="900" b="0" dirty="0" err="1">
-                <a:effectLst/>
-                <a:latin typeface="Menlo" panose="020B0609030804020204" pitchFamily="49" charset="0"/>
+              <a:rPr lang="en-US" sz="1000" dirty="0" err="1">
+                <a:latin typeface="Avenir Book" panose="02000503020000020003" pitchFamily="2" charset="0"/>
               </a:rPr>
               <a:t>c.city_id</a:t>
             </a:r>
             <a:r>
-              <a:rPr lang="en-US" sz="900" b="0" dirty="0">
-                <a:effectLst/>
-                <a:latin typeface="Menlo" panose="020B0609030804020204" pitchFamily="49" charset="0"/>
+              <a:rPr lang="en-US" sz="1000" dirty="0">
+                <a:latin typeface="Avenir Book" panose="02000503020000020003" pitchFamily="2" charset="0"/>
               </a:rPr>
               <a:t>)</a:t>
             </a:r>
           </a:p>
           <a:p>
-            <a:pPr>
-              <a:lnSpc>
-                <a:spcPts val="1350"/>
-              </a:lnSpc>
-              <a:buNone/>
-            </a:pPr>
-            <a:r>
-              <a:rPr lang="en-US" sz="900" b="0" dirty="0" err="1">
-                <a:effectLst/>
-                <a:latin typeface="Menlo" panose="020B0609030804020204" pitchFamily="49" charset="0"/>
+            <a:r>
+              <a:rPr lang="en-US" sz="1000" dirty="0" err="1">
+                <a:latin typeface="Avenir Book" panose="02000503020000020003" pitchFamily="2" charset="0"/>
               </a:rPr>
               <a:t>c.name</a:t>
             </a:r>
             <a:r>
-              <a:rPr lang="en-US" sz="900" b="0" dirty="0">
-                <a:effectLst/>
-                <a:latin typeface="Menlo" panose="020B0609030804020204" pitchFamily="49" charset="0"/>
+              <a:rPr lang="en-US" sz="1000" dirty="0">
+                <a:latin typeface="Avenir Book" panose="02000503020000020003" pitchFamily="2" charset="0"/>
               </a:rPr>
               <a:t> AS city,</a:t>
             </a:r>
           </a:p>
           <a:p>
-            <a:pPr>
-              <a:lnSpc>
-                <a:spcPts val="1350"/>
-              </a:lnSpc>
-              <a:buNone/>
-            </a:pPr>
-            <a:r>
-              <a:rPr lang="en-US" sz="900" b="0" dirty="0" err="1">
-                <a:effectLst/>
-                <a:latin typeface="Menlo" panose="020B0609030804020204" pitchFamily="49" charset="0"/>
+            <a:r>
+              <a:rPr lang="en-US" sz="1000" dirty="0" err="1">
+                <a:latin typeface="Avenir Book" panose="02000503020000020003" pitchFamily="2" charset="0"/>
               </a:rPr>
               <a:t>w.record_date</a:t>
             </a:r>
             <a:r>
-              <a:rPr lang="en-US" sz="900" b="0" dirty="0">
-                <a:effectLst/>
-                <a:latin typeface="Menlo" panose="020B0609030804020204" pitchFamily="49" charset="0"/>
+              <a:rPr lang="en-US" sz="1000" dirty="0">
+                <a:latin typeface="Avenir Book" panose="02000503020000020003" pitchFamily="2" charset="0"/>
               </a:rPr>
               <a:t>,</a:t>
             </a:r>
           </a:p>
           <a:p>
-            <a:pPr>
-              <a:lnSpc>
-                <a:spcPts val="1350"/>
-              </a:lnSpc>
-              <a:buNone/>
-            </a:pPr>
-            <a:r>
-              <a:rPr lang="en-US" sz="900" b="0" dirty="0" err="1">
-                <a:effectLst/>
-                <a:latin typeface="Menlo" panose="020B0609030804020204" pitchFamily="49" charset="0"/>
+            <a:r>
+              <a:rPr lang="en-US" sz="1000" dirty="0" err="1">
+                <a:latin typeface="Avenir Book" panose="02000503020000020003" pitchFamily="2" charset="0"/>
               </a:rPr>
               <a:t>w.temp_max_c</a:t>
             </a:r>
             <a:r>
-              <a:rPr lang="en-US" sz="900" b="0" dirty="0">
-                <a:effectLst/>
-                <a:latin typeface="Menlo" panose="020B0609030804020204" pitchFamily="49" charset="0"/>
-              </a:rPr>
-              <a:t> AS </a:t>
-            </a:r>
-            <a:r>
-              <a:rPr lang="en-US" sz="900" b="0" dirty="0" err="1">
-                <a:effectLst/>
-                <a:latin typeface="Menlo" panose="020B0609030804020204" pitchFamily="49" charset="0"/>
-              </a:rPr>
-              <a:t>hottest_max_temp_c</a:t>
-            </a:r>
-            <a:endParaRPr lang="en-US" sz="900" b="0" dirty="0">
-              <a:effectLst/>
-              <a:latin typeface="Menlo" panose="020B0609030804020204" pitchFamily="49" charset="0"/>
+              <a:rPr lang="en-US" sz="1000" dirty="0">
+                <a:latin typeface="Avenir Book" panose="02000503020000020003" pitchFamily="2" charset="0"/>
+              </a:rPr>
+              <a:t> AS `hottest max temp (</a:t>
+            </a:r>
+            <a:r>
+              <a:rPr lang="en-US" sz="1000" dirty="0" err="1">
+                <a:latin typeface="Avenir Book" panose="02000503020000020003" pitchFamily="2" charset="0"/>
+              </a:rPr>
+              <a:t>celsius</a:t>
+            </a:r>
+            <a:r>
+              <a:rPr lang="en-US" sz="1000" dirty="0">
+                <a:latin typeface="Avenir Book" panose="02000503020000020003" pitchFamily="2" charset="0"/>
+              </a:rPr>
+              <a:t>)`,</a:t>
+            </a:r>
+          </a:p>
+          <a:p>
+            <a:r>
+              <a:rPr lang="en-US" sz="1000" dirty="0">
+                <a:latin typeface="Avenir Book" panose="02000503020000020003" pitchFamily="2" charset="0"/>
+              </a:rPr>
+              <a:t>ROUND((</a:t>
+            </a:r>
+            <a:r>
+              <a:rPr lang="en-US" sz="1000" dirty="0" err="1">
+                <a:latin typeface="Avenir Book" panose="02000503020000020003" pitchFamily="2" charset="0"/>
+              </a:rPr>
+              <a:t>w.temp_max_c</a:t>
+            </a:r>
+            <a:r>
+              <a:rPr lang="en-US" sz="1000" dirty="0">
+                <a:latin typeface="Avenir Book" panose="02000503020000020003" pitchFamily="2" charset="0"/>
+              </a:rPr>
+              <a:t> * 9.0 / 5.0) + 32, 2) </a:t>
+            </a:r>
+          </a:p>
+          <a:p>
+            <a:r>
+              <a:rPr lang="en-US" sz="1000" dirty="0">
+                <a:latin typeface="Avenir Book" panose="02000503020000020003" pitchFamily="2" charset="0"/>
+              </a:rPr>
+              <a:t>AS `hottest max temp (</a:t>
+            </a:r>
+            <a:r>
+              <a:rPr lang="en-US" sz="1000" dirty="0" err="1">
+                <a:latin typeface="Avenir Book" panose="02000503020000020003" pitchFamily="2" charset="0"/>
+              </a:rPr>
+              <a:t>fahrenheit</a:t>
+            </a:r>
+            <a:r>
+              <a:rPr lang="en-US" sz="1000" dirty="0">
+                <a:latin typeface="Avenir Book" panose="02000503020000020003" pitchFamily="2" charset="0"/>
+              </a:rPr>
+              <a:t>)`</a:t>
+            </a:r>
+          </a:p>
+          <a:p>
+            <a:r>
+              <a:rPr lang="en-US" sz="1000" dirty="0">
+                <a:latin typeface="Avenir Book" panose="02000503020000020003" pitchFamily="2" charset="0"/>
+              </a:rPr>
+              <a:t>FROM weather w</a:t>
+            </a:r>
+          </a:p>
+          <a:p>
+            <a:r>
+              <a:rPr lang="en-US" sz="1000" dirty="0">
+                <a:latin typeface="Avenir Book" panose="02000503020000020003" pitchFamily="2" charset="0"/>
+              </a:rPr>
+              <a:t>JOIN cities c ON </a:t>
+            </a:r>
+            <a:r>
+              <a:rPr lang="en-US" sz="1000" dirty="0" err="1">
+                <a:latin typeface="Avenir Book" panose="02000503020000020003" pitchFamily="2" charset="0"/>
+              </a:rPr>
+              <a:t>c.city_id</a:t>
+            </a:r>
+            <a:r>
+              <a:rPr lang="en-US" sz="1000" dirty="0">
+                <a:latin typeface="Avenir Book" panose="02000503020000020003" pitchFamily="2" charset="0"/>
+              </a:rPr>
+              <a:t> = </a:t>
+            </a:r>
+            <a:r>
+              <a:rPr lang="en-US" sz="1000" dirty="0" err="1">
+                <a:latin typeface="Avenir Book" panose="02000503020000020003" pitchFamily="2" charset="0"/>
+              </a:rPr>
+              <a:t>w.city_id</a:t>
+            </a:r>
+            <a:endParaRPr lang="en-US" sz="1000" dirty="0">
+              <a:latin typeface="Avenir Book" panose="02000503020000020003" pitchFamily="2" charset="0"/>
             </a:endParaRPr>
           </a:p>
           <a:p>
-            <a:pPr>
-              <a:lnSpc>
-                <a:spcPts val="1350"/>
-              </a:lnSpc>
-              <a:buNone/>
-            </a:pPr>
-            <a:r>
-              <a:rPr lang="en-US" sz="900" b="0" dirty="0">
-                <a:effectLst/>
-                <a:latin typeface="Menlo" panose="020B0609030804020204" pitchFamily="49" charset="0"/>
-              </a:rPr>
-              <a:t>FROM weather w</a:t>
-            </a:r>
-          </a:p>
-          <a:p>
-            <a:pPr>
-              <a:lnSpc>
-                <a:spcPts val="1350"/>
-              </a:lnSpc>
-              <a:buNone/>
-            </a:pPr>
-            <a:r>
-              <a:rPr lang="en-US" sz="900" b="0" dirty="0">
-                <a:effectLst/>
-                <a:latin typeface="Menlo" panose="020B0609030804020204" pitchFamily="49" charset="0"/>
-              </a:rPr>
-              <a:t>JOIN cities c ON </a:t>
-            </a:r>
-            <a:r>
-              <a:rPr lang="en-US" sz="900" b="0" dirty="0" err="1">
-                <a:effectLst/>
-                <a:latin typeface="Menlo" panose="020B0609030804020204" pitchFamily="49" charset="0"/>
+            <a:r>
+              <a:rPr lang="en-US" sz="1000" dirty="0">
+                <a:latin typeface="Avenir Book" panose="02000503020000020003" pitchFamily="2" charset="0"/>
+              </a:rPr>
+              <a:t>ORDER BY </a:t>
+            </a:r>
+            <a:r>
+              <a:rPr lang="en-US" sz="1000" dirty="0" err="1">
+                <a:latin typeface="Avenir Book" panose="02000503020000020003" pitchFamily="2" charset="0"/>
               </a:rPr>
               <a:t>c.city_id</a:t>
             </a:r>
             <a:r>
-              <a:rPr lang="en-US" sz="900" b="0" dirty="0">
-                <a:effectLst/>
-                <a:latin typeface="Menlo" panose="020B0609030804020204" pitchFamily="49" charset="0"/>
-              </a:rPr>
-              <a:t> = </a:t>
-            </a:r>
-            <a:r>
-              <a:rPr lang="en-US" sz="900" b="0" dirty="0" err="1">
-                <a:effectLst/>
-                <a:latin typeface="Menlo" panose="020B0609030804020204" pitchFamily="49" charset="0"/>
-              </a:rPr>
-              <a:t>w.city_id</a:t>
-            </a:r>
-            <a:endParaRPr lang="en-US" sz="900" b="0" dirty="0">
-              <a:effectLst/>
-              <a:latin typeface="Menlo" panose="020B0609030804020204" pitchFamily="49" charset="0"/>
-            </a:endParaRPr>
-          </a:p>
-          <a:p>
-            <a:pPr>
-              <a:lnSpc>
-                <a:spcPts val="1350"/>
-              </a:lnSpc>
-              <a:buNone/>
-            </a:pPr>
-            <a:r>
-              <a:rPr lang="en-US" sz="900" b="0" dirty="0">
-                <a:effectLst/>
-                <a:latin typeface="Menlo" panose="020B0609030804020204" pitchFamily="49" charset="0"/>
-              </a:rPr>
-              <a:t>ORDER BY </a:t>
-            </a:r>
-            <a:r>
-              <a:rPr lang="en-US" sz="900" b="0" dirty="0" err="1">
-                <a:effectLst/>
-                <a:latin typeface="Menlo" panose="020B0609030804020204" pitchFamily="49" charset="0"/>
-              </a:rPr>
-              <a:t>c.city_id</a:t>
-            </a:r>
-            <a:r>
-              <a:rPr lang="en-US" sz="900" b="0" dirty="0">
-                <a:effectLst/>
-                <a:latin typeface="Menlo" panose="020B0609030804020204" pitchFamily="49" charset="0"/>
+              <a:rPr lang="en-US" sz="1000" dirty="0">
+                <a:latin typeface="Avenir Book" panose="02000503020000020003" pitchFamily="2" charset="0"/>
               </a:rPr>
               <a:t>, </a:t>
             </a:r>
             <a:r>
-              <a:rPr lang="en-US" sz="900" b="0" dirty="0" err="1">
-                <a:effectLst/>
-                <a:latin typeface="Menlo" panose="020B0609030804020204" pitchFamily="49" charset="0"/>
+              <a:rPr lang="en-US" sz="1000" dirty="0" err="1">
+                <a:latin typeface="Avenir Book" panose="02000503020000020003" pitchFamily="2" charset="0"/>
               </a:rPr>
               <a:t>w.temp_max_c</a:t>
             </a:r>
             <a:r>
-              <a:rPr lang="en-US" sz="900" b="0" dirty="0">
-                <a:effectLst/>
-                <a:latin typeface="Menlo" panose="020B0609030804020204" pitchFamily="49" charset="0"/>
+              <a:rPr lang="en-US" sz="1000" dirty="0">
+                <a:latin typeface="Avenir Book" panose="02000503020000020003" pitchFamily="2" charset="0"/>
               </a:rPr>
               <a:t> DESC, </a:t>
             </a:r>
             <a:r>
-              <a:rPr lang="en-US" sz="900" b="0" dirty="0" err="1">
-                <a:effectLst/>
-                <a:latin typeface="Menlo" panose="020B0609030804020204" pitchFamily="49" charset="0"/>
+              <a:rPr lang="en-US" sz="1000" dirty="0" err="1">
+                <a:latin typeface="Avenir Book" panose="02000503020000020003" pitchFamily="2" charset="0"/>
               </a:rPr>
               <a:t>w.record_date</a:t>
             </a:r>
             <a:r>
-              <a:rPr lang="en-US" sz="900" b="0" dirty="0">
-                <a:effectLst/>
-                <a:latin typeface="Menlo" panose="020B0609030804020204" pitchFamily="49" charset="0"/>
+              <a:rPr lang="en-US" sz="1000" dirty="0">
+                <a:latin typeface="Avenir Book" panose="02000503020000020003" pitchFamily="2" charset="0"/>
               </a:rPr>
               <a:t>;</a:t>
             </a:r>
@@ -6411,8 +6449,8 @@
         </p:nvSpPr>
         <p:spPr>
           <a:xfrm>
-            <a:off x="7873843" y="2246980"/>
-            <a:ext cx="4194587" cy="3131498"/>
+            <a:off x="7756276" y="2246980"/>
+            <a:ext cx="4194587" cy="2792944"/>
           </a:xfrm>
           <a:prstGeom prst="rect">
             <a:avLst/>
@@ -6425,320 +6463,293 @@
           </a:bodyPr>
           <a:lstStyle/>
           <a:p>
-            <a:pPr>
-              <a:lnSpc>
-                <a:spcPts val="1350"/>
-              </a:lnSpc>
-              <a:buNone/>
-            </a:pPr>
             <a:r>
               <a:rPr lang="en-US" sz="900" b="1" dirty="0">
                 <a:effectLst/>
                 <a:latin typeface="Menlo" panose="020B0609030804020204" pitchFamily="49" charset="0"/>
-              </a:rPr>
-              <a:t>-- Query 5: Determine frequency of extreme heat days (max temp &gt;= 86°C)</a:t>
-            </a:r>
-          </a:p>
-          <a:p>
-            <a:pPr>
-              <a:lnSpc>
-                <a:spcPts val="1350"/>
-              </a:lnSpc>
-              <a:buNone/>
-            </a:pPr>
-            <a:r>
-              <a:rPr lang="en-US" sz="900" b="0" dirty="0">
-                <a:effectLst/>
-                <a:latin typeface="Menlo" panose="020B0609030804020204" pitchFamily="49" charset="0"/>
+                <a:ea typeface="Menlo" panose="020B0609030804020204" pitchFamily="49" charset="0"/>
+                <a:cs typeface="Menlo" panose="020B0609030804020204" pitchFamily="49" charset="0"/>
+              </a:rPr>
+              <a:t>-- Query 5: Determine frequency of extreme heat days (max </a:t>
+            </a:r>
+            <a:r>
+              <a:rPr lang="en-US" sz="900" dirty="0">
+                <a:latin typeface="Menlo" panose="020B0609030804020204" pitchFamily="49" charset="0"/>
+                <a:ea typeface="Menlo" panose="020B0609030804020204" pitchFamily="49" charset="0"/>
+                <a:cs typeface="Menlo" panose="020B0609030804020204" pitchFamily="49" charset="0"/>
+              </a:rPr>
+              <a:t>\echo '--------------- Query 5: Frequency of extreme heat (max temp &gt;= 86°C) ---------------\n'</a:t>
+            </a:r>
+          </a:p>
+          <a:p>
+            <a:r>
+              <a:rPr lang="en-US" sz="900" dirty="0">
+                <a:latin typeface="Menlo" panose="020B0609030804020204" pitchFamily="49" charset="0"/>
+                <a:ea typeface="Menlo" panose="020B0609030804020204" pitchFamily="49" charset="0"/>
+                <a:cs typeface="Menlo" panose="020B0609030804020204" pitchFamily="49" charset="0"/>
+              </a:rPr>
+              <a:t>\echo ''</a:t>
+            </a:r>
+          </a:p>
+          <a:p>
+            <a:r>
+              <a:rPr lang="en-US" sz="900" dirty="0">
+                <a:latin typeface="Menlo" panose="020B0609030804020204" pitchFamily="49" charset="0"/>
+                <a:ea typeface="Menlo" panose="020B0609030804020204" pitchFamily="49" charset="0"/>
+                <a:cs typeface="Menlo" panose="020B0609030804020204" pitchFamily="49" charset="0"/>
               </a:rPr>
               <a:t>SELECT</a:t>
             </a:r>
           </a:p>
           <a:p>
-            <a:pPr>
-              <a:lnSpc>
-                <a:spcPts val="1350"/>
-              </a:lnSpc>
-              <a:buNone/>
-            </a:pPr>
-            <a:r>
-              <a:rPr lang="en-US" sz="900" b="0" dirty="0" err="1">
-                <a:effectLst/>
-                <a:latin typeface="Menlo" panose="020B0609030804020204" pitchFamily="49" charset="0"/>
+            <a:r>
+              <a:rPr lang="en-US" sz="900" dirty="0" err="1">
+                <a:latin typeface="Menlo" panose="020B0609030804020204" pitchFamily="49" charset="0"/>
+                <a:ea typeface="Menlo" panose="020B0609030804020204" pitchFamily="49" charset="0"/>
+                <a:cs typeface="Menlo" panose="020B0609030804020204" pitchFamily="49" charset="0"/>
               </a:rPr>
               <a:t>c.name</a:t>
             </a:r>
             <a:r>
-              <a:rPr lang="en-US" sz="900" b="0" dirty="0">
-                <a:effectLst/>
-                <a:latin typeface="Menlo" panose="020B0609030804020204" pitchFamily="49" charset="0"/>
+              <a:rPr lang="en-US" sz="900" dirty="0">
+                <a:latin typeface="Menlo" panose="020B0609030804020204" pitchFamily="49" charset="0"/>
+                <a:ea typeface="Menlo" panose="020B0609030804020204" pitchFamily="49" charset="0"/>
+                <a:cs typeface="Menlo" panose="020B0609030804020204" pitchFamily="49" charset="0"/>
               </a:rPr>
               <a:t> AS city,</a:t>
             </a:r>
           </a:p>
           <a:p>
-            <a:pPr>
-              <a:lnSpc>
-                <a:spcPts val="1350"/>
-              </a:lnSpc>
-              <a:buNone/>
-            </a:pPr>
-            <a:r>
-              <a:rPr lang="en-US" sz="900" b="0" dirty="0">
-                <a:effectLst/>
-                <a:latin typeface="Menlo" panose="020B0609030804020204" pitchFamily="49" charset="0"/>
+            <a:r>
+              <a:rPr lang="en-US" sz="900" dirty="0">
+                <a:latin typeface="Menlo" panose="020B0609030804020204" pitchFamily="49" charset="0"/>
+                <a:ea typeface="Menlo" panose="020B0609030804020204" pitchFamily="49" charset="0"/>
+                <a:cs typeface="Menlo" panose="020B0609030804020204" pitchFamily="49" charset="0"/>
               </a:rPr>
               <a:t>COUNT(*) FILTER (WHERE </a:t>
             </a:r>
             <a:r>
-              <a:rPr lang="en-US" sz="900" b="0" dirty="0" err="1">
-                <a:effectLst/>
-                <a:latin typeface="Menlo" panose="020B0609030804020204" pitchFamily="49" charset="0"/>
+              <a:rPr lang="en-US" sz="900" dirty="0" err="1">
+                <a:latin typeface="Menlo" panose="020B0609030804020204" pitchFamily="49" charset="0"/>
+                <a:ea typeface="Menlo" panose="020B0609030804020204" pitchFamily="49" charset="0"/>
+                <a:cs typeface="Menlo" panose="020B0609030804020204" pitchFamily="49" charset="0"/>
               </a:rPr>
               <a:t>w.temp_max_c</a:t>
             </a:r>
             <a:r>
-              <a:rPr lang="en-US" sz="900" b="0" dirty="0">
-                <a:effectLst/>
-                <a:latin typeface="Menlo" panose="020B0609030804020204" pitchFamily="49" charset="0"/>
-              </a:rPr>
-              <a:t> &gt;= 40) AS </a:t>
-            </a:r>
-            <a:r>
-              <a:rPr lang="en-US" sz="900" b="0" dirty="0" err="1">
-                <a:effectLst/>
-                <a:latin typeface="Menlo" panose="020B0609030804020204" pitchFamily="49" charset="0"/>
+              <a:rPr lang="en-US" sz="900" dirty="0">
+                <a:latin typeface="Menlo" panose="020B0609030804020204" pitchFamily="49" charset="0"/>
+                <a:ea typeface="Menlo" panose="020B0609030804020204" pitchFamily="49" charset="0"/>
+                <a:cs typeface="Menlo" panose="020B0609030804020204" pitchFamily="49" charset="0"/>
+              </a:rPr>
+              <a:t> &gt;= 30) AS </a:t>
+            </a:r>
+            <a:r>
+              <a:rPr lang="en-US" sz="900" dirty="0" err="1">
+                <a:latin typeface="Menlo" panose="020B0609030804020204" pitchFamily="49" charset="0"/>
+                <a:ea typeface="Menlo" panose="020B0609030804020204" pitchFamily="49" charset="0"/>
+                <a:cs typeface="Menlo" panose="020B0609030804020204" pitchFamily="49" charset="0"/>
               </a:rPr>
               <a:t>hot_days</a:t>
             </a:r>
             <a:r>
-              <a:rPr lang="en-US" sz="900" b="0" dirty="0">
-                <a:effectLst/>
-                <a:latin typeface="Menlo" panose="020B0609030804020204" pitchFamily="49" charset="0"/>
+              <a:rPr lang="en-US" sz="900" dirty="0">
+                <a:latin typeface="Menlo" panose="020B0609030804020204" pitchFamily="49" charset="0"/>
+                <a:ea typeface="Menlo" panose="020B0609030804020204" pitchFamily="49" charset="0"/>
+                <a:cs typeface="Menlo" panose="020B0609030804020204" pitchFamily="49" charset="0"/>
               </a:rPr>
               <a:t>,</a:t>
             </a:r>
           </a:p>
           <a:p>
-            <a:pPr>
-              <a:lnSpc>
-                <a:spcPts val="1350"/>
-              </a:lnSpc>
-              <a:buNone/>
-            </a:pPr>
-            <a:r>
-              <a:rPr lang="en-US" sz="900" b="0" dirty="0">
-                <a:effectLst/>
-                <a:latin typeface="Menlo" panose="020B0609030804020204" pitchFamily="49" charset="0"/>
+            <a:r>
+              <a:rPr lang="en-US" sz="900" dirty="0">
+                <a:latin typeface="Menlo" panose="020B0609030804020204" pitchFamily="49" charset="0"/>
+                <a:ea typeface="Menlo" panose="020B0609030804020204" pitchFamily="49" charset="0"/>
+                <a:cs typeface="Menlo" panose="020B0609030804020204" pitchFamily="49" charset="0"/>
               </a:rPr>
               <a:t>COUNT(*) AS </a:t>
             </a:r>
             <a:r>
-              <a:rPr lang="en-US" sz="900" b="0" dirty="0" err="1">
-                <a:effectLst/>
-                <a:latin typeface="Menlo" panose="020B0609030804020204" pitchFamily="49" charset="0"/>
+              <a:rPr lang="en-US" sz="900" dirty="0" err="1">
+                <a:latin typeface="Menlo" panose="020B0609030804020204" pitchFamily="49" charset="0"/>
+                <a:ea typeface="Menlo" panose="020B0609030804020204" pitchFamily="49" charset="0"/>
+                <a:cs typeface="Menlo" panose="020B0609030804020204" pitchFamily="49" charset="0"/>
               </a:rPr>
               <a:t>total_days</a:t>
             </a:r>
             <a:r>
-              <a:rPr lang="en-US" sz="900" b="0" dirty="0">
-                <a:effectLst/>
-                <a:latin typeface="Menlo" panose="020B0609030804020204" pitchFamily="49" charset="0"/>
+              <a:rPr lang="en-US" sz="900" dirty="0">
+                <a:latin typeface="Menlo" panose="020B0609030804020204" pitchFamily="49" charset="0"/>
+                <a:ea typeface="Menlo" panose="020B0609030804020204" pitchFamily="49" charset="0"/>
+                <a:cs typeface="Menlo" panose="020B0609030804020204" pitchFamily="49" charset="0"/>
               </a:rPr>
               <a:t>,</a:t>
             </a:r>
           </a:p>
           <a:p>
-            <a:pPr>
-              <a:lnSpc>
-                <a:spcPts val="1350"/>
-              </a:lnSpc>
-              <a:buNone/>
-            </a:pPr>
-            <a:r>
-              <a:rPr lang="en-US" sz="900" b="0" dirty="0">
-                <a:effectLst/>
-                <a:latin typeface="Menlo" panose="020B0609030804020204" pitchFamily="49" charset="0"/>
+            <a:r>
+              <a:rPr lang="en-US" sz="900" dirty="0">
+                <a:latin typeface="Menlo" panose="020B0609030804020204" pitchFamily="49" charset="0"/>
+                <a:ea typeface="Menlo" panose="020B0609030804020204" pitchFamily="49" charset="0"/>
+                <a:cs typeface="Menlo" panose="020B0609030804020204" pitchFamily="49" charset="0"/>
               </a:rPr>
               <a:t>ROUND(</a:t>
             </a:r>
           </a:p>
           <a:p>
-            <a:pPr>
-              <a:lnSpc>
-                <a:spcPts val="1350"/>
-              </a:lnSpc>
-              <a:buNone/>
-            </a:pPr>
-            <a:r>
-              <a:rPr lang="en-US" sz="900" b="0" dirty="0">
-                <a:effectLst/>
-                <a:latin typeface="Menlo" panose="020B0609030804020204" pitchFamily="49" charset="0"/>
+            <a:r>
+              <a:rPr lang="en-US" sz="900" dirty="0">
+                <a:latin typeface="Menlo" panose="020B0609030804020204" pitchFamily="49" charset="0"/>
+                <a:ea typeface="Menlo" panose="020B0609030804020204" pitchFamily="49" charset="0"/>
+                <a:cs typeface="Menlo" panose="020B0609030804020204" pitchFamily="49" charset="0"/>
               </a:rPr>
               <a:t>100.0 * COUNT(*) FILTER (WHERE </a:t>
             </a:r>
             <a:r>
-              <a:rPr lang="en-US" sz="900" b="0" dirty="0" err="1">
-                <a:effectLst/>
-                <a:latin typeface="Menlo" panose="020B0609030804020204" pitchFamily="49" charset="0"/>
+              <a:rPr lang="en-US" sz="900" dirty="0" err="1">
+                <a:latin typeface="Menlo" panose="020B0609030804020204" pitchFamily="49" charset="0"/>
+                <a:ea typeface="Menlo" panose="020B0609030804020204" pitchFamily="49" charset="0"/>
+                <a:cs typeface="Menlo" panose="020B0609030804020204" pitchFamily="49" charset="0"/>
               </a:rPr>
               <a:t>w.temp_max_c</a:t>
             </a:r>
             <a:r>
-              <a:rPr lang="en-US" sz="900" b="0" dirty="0">
-                <a:effectLst/>
-                <a:latin typeface="Menlo" panose="020B0609030804020204" pitchFamily="49" charset="0"/>
-              </a:rPr>
-              <a:t> &gt;= 40) / COUNT(*),</a:t>
-            </a:r>
-          </a:p>
-          <a:p>
-            <a:pPr>
-              <a:lnSpc>
-                <a:spcPts val="1350"/>
-              </a:lnSpc>
-              <a:buNone/>
-            </a:pPr>
-            <a:r>
-              <a:rPr lang="en-US" sz="900" b="0" dirty="0">
-                <a:effectLst/>
-                <a:latin typeface="Menlo" panose="020B0609030804020204" pitchFamily="49" charset="0"/>
+              <a:rPr lang="en-US" sz="900" dirty="0">
+                <a:latin typeface="Menlo" panose="020B0609030804020204" pitchFamily="49" charset="0"/>
+                <a:ea typeface="Menlo" panose="020B0609030804020204" pitchFamily="49" charset="0"/>
+                <a:cs typeface="Menlo" panose="020B0609030804020204" pitchFamily="49" charset="0"/>
+              </a:rPr>
+              <a:t> &gt;= 30) / COUNT(*),</a:t>
+            </a:r>
+          </a:p>
+          <a:p>
+            <a:r>
+              <a:rPr lang="en-US" sz="900" dirty="0">
+                <a:latin typeface="Menlo" panose="020B0609030804020204" pitchFamily="49" charset="0"/>
+                <a:ea typeface="Menlo" panose="020B0609030804020204" pitchFamily="49" charset="0"/>
+                <a:cs typeface="Menlo" panose="020B0609030804020204" pitchFamily="49" charset="0"/>
               </a:rPr>
               <a:t>1</a:t>
             </a:r>
           </a:p>
           <a:p>
-            <a:pPr>
-              <a:lnSpc>
-                <a:spcPts val="1350"/>
-              </a:lnSpc>
-              <a:buNone/>
-            </a:pPr>
-            <a:r>
-              <a:rPr lang="en-US" sz="900" b="0" dirty="0">
-                <a:effectLst/>
-                <a:latin typeface="Menlo" panose="020B0609030804020204" pitchFamily="49" charset="0"/>
+            <a:r>
+              <a:rPr lang="en-US" sz="900" dirty="0">
+                <a:latin typeface="Menlo" panose="020B0609030804020204" pitchFamily="49" charset="0"/>
+                <a:ea typeface="Menlo" panose="020B0609030804020204" pitchFamily="49" charset="0"/>
+                <a:cs typeface="Menlo" panose="020B0609030804020204" pitchFamily="49" charset="0"/>
               </a:rPr>
               <a:t>) AS </a:t>
             </a:r>
             <a:r>
-              <a:rPr lang="en-US" sz="900" b="0" dirty="0" err="1">
-                <a:effectLst/>
-                <a:latin typeface="Menlo" panose="020B0609030804020204" pitchFamily="49" charset="0"/>
+              <a:rPr lang="en-US" sz="900" dirty="0" err="1">
+                <a:latin typeface="Menlo" panose="020B0609030804020204" pitchFamily="49" charset="0"/>
+                <a:ea typeface="Menlo" panose="020B0609030804020204" pitchFamily="49" charset="0"/>
+                <a:cs typeface="Menlo" panose="020B0609030804020204" pitchFamily="49" charset="0"/>
               </a:rPr>
               <a:t>pct_hot_days</a:t>
             </a:r>
-            <a:endParaRPr lang="en-US" sz="900" b="0" dirty="0">
-              <a:effectLst/>
+            <a:endParaRPr lang="en-US" sz="900" dirty="0">
               <a:latin typeface="Menlo" panose="020B0609030804020204" pitchFamily="49" charset="0"/>
+              <a:ea typeface="Menlo" panose="020B0609030804020204" pitchFamily="49" charset="0"/>
+              <a:cs typeface="Menlo" panose="020B0609030804020204" pitchFamily="49" charset="0"/>
             </a:endParaRPr>
           </a:p>
           <a:p>
-            <a:pPr>
-              <a:lnSpc>
-                <a:spcPts val="1350"/>
-              </a:lnSpc>
-              <a:buNone/>
-            </a:pPr>
-            <a:r>
-              <a:rPr lang="en-US" sz="900" b="0" dirty="0">
-                <a:effectLst/>
-                <a:latin typeface="Menlo" panose="020B0609030804020204" pitchFamily="49" charset="0"/>
+            <a:r>
+              <a:rPr lang="en-US" sz="900" dirty="0">
+                <a:latin typeface="Menlo" panose="020B0609030804020204" pitchFamily="49" charset="0"/>
+                <a:ea typeface="Menlo" panose="020B0609030804020204" pitchFamily="49" charset="0"/>
+                <a:cs typeface="Menlo" panose="020B0609030804020204" pitchFamily="49" charset="0"/>
               </a:rPr>
               <a:t>FROM weather w</a:t>
             </a:r>
           </a:p>
           <a:p>
-            <a:pPr>
-              <a:lnSpc>
-                <a:spcPts val="1350"/>
-              </a:lnSpc>
-              <a:buNone/>
-            </a:pPr>
-            <a:r>
-              <a:rPr lang="en-US" sz="900" b="0" dirty="0">
-                <a:effectLst/>
-                <a:latin typeface="Menlo" panose="020B0609030804020204" pitchFamily="49" charset="0"/>
+            <a:r>
+              <a:rPr lang="en-US" sz="900" dirty="0">
+                <a:latin typeface="Menlo" panose="020B0609030804020204" pitchFamily="49" charset="0"/>
+                <a:ea typeface="Menlo" panose="020B0609030804020204" pitchFamily="49" charset="0"/>
+                <a:cs typeface="Menlo" panose="020B0609030804020204" pitchFamily="49" charset="0"/>
               </a:rPr>
               <a:t>JOIN cities c ON </a:t>
             </a:r>
             <a:r>
-              <a:rPr lang="en-US" sz="900" b="0" dirty="0" err="1">
-                <a:effectLst/>
-                <a:latin typeface="Menlo" panose="020B0609030804020204" pitchFamily="49" charset="0"/>
+              <a:rPr lang="en-US" sz="900" dirty="0" err="1">
+                <a:latin typeface="Menlo" panose="020B0609030804020204" pitchFamily="49" charset="0"/>
+                <a:ea typeface="Menlo" panose="020B0609030804020204" pitchFamily="49" charset="0"/>
+                <a:cs typeface="Menlo" panose="020B0609030804020204" pitchFamily="49" charset="0"/>
               </a:rPr>
               <a:t>c.city_id</a:t>
             </a:r>
             <a:r>
-              <a:rPr lang="en-US" sz="900" b="0" dirty="0">
-                <a:effectLst/>
-                <a:latin typeface="Menlo" panose="020B0609030804020204" pitchFamily="49" charset="0"/>
+              <a:rPr lang="en-US" sz="900" dirty="0">
+                <a:latin typeface="Menlo" panose="020B0609030804020204" pitchFamily="49" charset="0"/>
+                <a:ea typeface="Menlo" panose="020B0609030804020204" pitchFamily="49" charset="0"/>
+                <a:cs typeface="Menlo" panose="020B0609030804020204" pitchFamily="49" charset="0"/>
               </a:rPr>
               <a:t> = </a:t>
             </a:r>
             <a:r>
-              <a:rPr lang="en-US" sz="900" b="0" dirty="0" err="1">
-                <a:effectLst/>
-                <a:latin typeface="Menlo" panose="020B0609030804020204" pitchFamily="49" charset="0"/>
+              <a:rPr lang="en-US" sz="900" dirty="0" err="1">
+                <a:latin typeface="Menlo" panose="020B0609030804020204" pitchFamily="49" charset="0"/>
+                <a:ea typeface="Menlo" panose="020B0609030804020204" pitchFamily="49" charset="0"/>
+                <a:cs typeface="Menlo" panose="020B0609030804020204" pitchFamily="49" charset="0"/>
               </a:rPr>
               <a:t>w.city_id</a:t>
             </a:r>
-            <a:endParaRPr lang="en-US" sz="900" b="0" dirty="0">
-              <a:effectLst/>
+            <a:endParaRPr lang="en-US" sz="900" dirty="0">
               <a:latin typeface="Menlo" panose="020B0609030804020204" pitchFamily="49" charset="0"/>
+              <a:ea typeface="Menlo" panose="020B0609030804020204" pitchFamily="49" charset="0"/>
+              <a:cs typeface="Menlo" panose="020B0609030804020204" pitchFamily="49" charset="0"/>
             </a:endParaRPr>
           </a:p>
           <a:p>
-            <a:pPr>
-              <a:lnSpc>
-                <a:spcPts val="1350"/>
-              </a:lnSpc>
-              <a:buNone/>
-            </a:pPr>
-            <a:r>
-              <a:rPr lang="en-US" sz="900" b="0" dirty="0">
-                <a:effectLst/>
-                <a:latin typeface="Menlo" panose="020B0609030804020204" pitchFamily="49" charset="0"/>
+            <a:r>
+              <a:rPr lang="en-US" sz="900" dirty="0">
+                <a:latin typeface="Menlo" panose="020B0609030804020204" pitchFamily="49" charset="0"/>
+                <a:ea typeface="Menlo" panose="020B0609030804020204" pitchFamily="49" charset="0"/>
+                <a:cs typeface="Menlo" panose="020B0609030804020204" pitchFamily="49" charset="0"/>
               </a:rPr>
               <a:t>GROUP BY </a:t>
             </a:r>
             <a:r>
-              <a:rPr lang="en-US" sz="900" b="0" dirty="0" err="1">
-                <a:effectLst/>
-                <a:latin typeface="Menlo" panose="020B0609030804020204" pitchFamily="49" charset="0"/>
+              <a:rPr lang="en-US" sz="900" dirty="0" err="1">
+                <a:latin typeface="Menlo" panose="020B0609030804020204" pitchFamily="49" charset="0"/>
+                <a:ea typeface="Menlo" panose="020B0609030804020204" pitchFamily="49" charset="0"/>
+                <a:cs typeface="Menlo" panose="020B0609030804020204" pitchFamily="49" charset="0"/>
               </a:rPr>
               <a:t>c.name</a:t>
             </a:r>
-            <a:endParaRPr lang="en-US" sz="900" b="0" dirty="0">
-              <a:effectLst/>
+            <a:endParaRPr lang="en-US" sz="900" dirty="0">
               <a:latin typeface="Menlo" panose="020B0609030804020204" pitchFamily="49" charset="0"/>
+              <a:ea typeface="Menlo" panose="020B0609030804020204" pitchFamily="49" charset="0"/>
+              <a:cs typeface="Menlo" panose="020B0609030804020204" pitchFamily="49" charset="0"/>
             </a:endParaRPr>
           </a:p>
           <a:p>
-            <a:pPr>
-              <a:lnSpc>
-                <a:spcPts val="1350"/>
-              </a:lnSpc>
-              <a:buNone/>
-            </a:pPr>
-            <a:r>
-              <a:rPr lang="en-US" sz="900" b="0" dirty="0">
-                <a:effectLst/>
-                <a:latin typeface="Menlo" panose="020B0609030804020204" pitchFamily="49" charset="0"/>
+            <a:r>
+              <a:rPr lang="en-US" sz="900" dirty="0">
+                <a:latin typeface="Menlo" panose="020B0609030804020204" pitchFamily="49" charset="0"/>
+                <a:ea typeface="Menlo" panose="020B0609030804020204" pitchFamily="49" charset="0"/>
+                <a:cs typeface="Menlo" panose="020B0609030804020204" pitchFamily="49" charset="0"/>
               </a:rPr>
               <a:t>ORDER BY </a:t>
             </a:r>
             <a:r>
-              <a:rPr lang="en-US" sz="900" b="0" dirty="0" err="1">
-                <a:effectLst/>
-                <a:latin typeface="Menlo" panose="020B0609030804020204" pitchFamily="49" charset="0"/>
+              <a:rPr lang="en-US" sz="900" dirty="0" err="1">
+                <a:latin typeface="Menlo" panose="020B0609030804020204" pitchFamily="49" charset="0"/>
+                <a:ea typeface="Menlo" panose="020B0609030804020204" pitchFamily="49" charset="0"/>
+                <a:cs typeface="Menlo" panose="020B0609030804020204" pitchFamily="49" charset="0"/>
               </a:rPr>
               <a:t>hot_days</a:t>
             </a:r>
             <a:r>
-              <a:rPr lang="en-US" sz="900" b="0" dirty="0">
-                <a:effectLst/>
-                <a:latin typeface="Menlo" panose="020B0609030804020204" pitchFamily="49" charset="0"/>
+              <a:rPr lang="en-US" sz="900" dirty="0">
+                <a:latin typeface="Menlo" panose="020B0609030804020204" pitchFamily="49" charset="0"/>
+                <a:ea typeface="Menlo" panose="020B0609030804020204" pitchFamily="49" charset="0"/>
+                <a:cs typeface="Menlo" panose="020B0609030804020204" pitchFamily="49" charset="0"/>
               </a:rPr>
               <a:t> DESC;</a:t>
             </a:r>

</xml_diff>

<commit_message>
Made minor adjustment to query #5
</commit_message>
<xml_diff>
--- a/Weather Analytics Platform.pptx
+++ b/Weather Analytics Platform.pptx
@@ -3675,69 +3675,6 @@
           </a:prstGeom>
         </p:spPr>
       </p:pic>
-      <p:sp>
-        <p:nvSpPr>
-          <p:cNvPr id="13" name="TextBox 12">
-            <a:extLst>
-              <a:ext uri="{FF2B5EF4-FFF2-40B4-BE49-F238E27FC236}">
-                <a16:creationId xmlns:a16="http://schemas.microsoft.com/office/drawing/2014/main" id="{5D5E9634-667B-66C3-0CE9-56AA0A35824E}"/>
-              </a:ext>
-            </a:extLst>
-          </p:cNvPr>
-          <p:cNvSpPr txBox="1"/>
-          <p:nvPr/>
-        </p:nvSpPr>
-        <p:spPr>
-          <a:xfrm>
-            <a:off x="1264409" y="3163329"/>
-            <a:ext cx="8423288" cy="338554"/>
-          </a:xfrm>
-          <a:prstGeom prst="rect">
-            <a:avLst/>
-          </a:prstGeom>
-          <a:noFill/>
-          <a:ln>
-            <a:gradFill>
-              <a:gsLst>
-                <a:gs pos="0">
-                  <a:schemeClr val="accent1">
-                    <a:lumMod val="5000"/>
-                    <a:lumOff val="95000"/>
-                  </a:schemeClr>
-                </a:gs>
-                <a:gs pos="74000">
-                  <a:schemeClr val="accent1">
-                    <a:lumMod val="45000"/>
-                    <a:lumOff val="55000"/>
-                  </a:schemeClr>
-                </a:gs>
-                <a:gs pos="83000">
-                  <a:schemeClr val="accent1">
-                    <a:lumMod val="45000"/>
-                    <a:lumOff val="55000"/>
-                  </a:schemeClr>
-                </a:gs>
-                <a:gs pos="100000">
-                  <a:schemeClr val="accent1">
-                    <a:lumMod val="30000"/>
-                    <a:lumOff val="70000"/>
-                  </a:schemeClr>
-                </a:gs>
-              </a:gsLst>
-              <a:lin ang="5400000" scaled="1"/>
-            </a:gradFill>
-          </a:ln>
-        </p:spPr>
-        <p:txBody>
-          <a:bodyPr wrap="square">
-            <a:spAutoFit/>
-          </a:bodyPr>
-          <a:lstStyle/>
-          <a:p>
-            <a:endParaRPr lang="en-US" sz="1600" dirty="0"/>
-          </a:p>
-        </p:txBody>
-      </p:sp>
       <p:pic>
         <p:nvPicPr>
           <p:cNvPr id="15" name="Picture 14">

</xml_diff>

<commit_message>
Made minor adjustment to powerpoint
</commit_message>
<xml_diff>
--- a/Weather Analytics Platform.pptx
+++ b/Weather Analytics Platform.pptx
@@ -5255,201 +5255,263 @@
               <a:rPr lang="en-US" sz="900" b="1" dirty="0">
                 <a:effectLst/>
                 <a:latin typeface="Menlo" panose="020B0609030804020204" pitchFamily="49" charset="0"/>
+                <a:ea typeface="Menlo" panose="020B0609030804020204" pitchFamily="49" charset="0"/>
+                <a:cs typeface="Menlo" panose="020B0609030804020204" pitchFamily="49" charset="0"/>
               </a:rPr>
               <a:t>-- Query 1: Find the highest temperature per city</a:t>
             </a:r>
           </a:p>
           <a:p>
             <a:r>
-              <a:rPr lang="en-US" sz="1000" dirty="0">
-                <a:latin typeface="Avenir Book" panose="02000503020000020003" pitchFamily="2" charset="0"/>
+              <a:rPr lang="en-US" sz="900" dirty="0">
+                <a:latin typeface="Menlo" panose="020B0609030804020204" pitchFamily="49" charset="0"/>
+                <a:ea typeface="Menlo" panose="020B0609030804020204" pitchFamily="49" charset="0"/>
+                <a:cs typeface="Menlo" panose="020B0609030804020204" pitchFamily="49" charset="0"/>
               </a:rPr>
               <a:t>SELECT DISTINCT ON (</a:t>
             </a:r>
             <a:r>
-              <a:rPr lang="en-US" sz="1000" dirty="0" err="1">
-                <a:latin typeface="Avenir Book" panose="02000503020000020003" pitchFamily="2" charset="0"/>
+              <a:rPr lang="en-US" sz="900" dirty="0" err="1">
+                <a:latin typeface="Menlo" panose="020B0609030804020204" pitchFamily="49" charset="0"/>
+                <a:ea typeface="Menlo" panose="020B0609030804020204" pitchFamily="49" charset="0"/>
+                <a:cs typeface="Menlo" panose="020B0609030804020204" pitchFamily="49" charset="0"/>
               </a:rPr>
               <a:t>c.city_id</a:t>
             </a:r>
             <a:r>
-              <a:rPr lang="en-US" sz="1000" dirty="0">
-                <a:latin typeface="Avenir Book" panose="02000503020000020003" pitchFamily="2" charset="0"/>
+              <a:rPr lang="en-US" sz="900" dirty="0">
+                <a:latin typeface="Menlo" panose="020B0609030804020204" pitchFamily="49" charset="0"/>
+                <a:ea typeface="Menlo" panose="020B0609030804020204" pitchFamily="49" charset="0"/>
+                <a:cs typeface="Menlo" panose="020B0609030804020204" pitchFamily="49" charset="0"/>
               </a:rPr>
               <a:t>)</a:t>
             </a:r>
           </a:p>
           <a:p>
             <a:r>
-              <a:rPr lang="en-US" sz="1000" dirty="0" err="1">
-                <a:latin typeface="Avenir Book" panose="02000503020000020003" pitchFamily="2" charset="0"/>
+              <a:rPr lang="en-US" sz="900" dirty="0" err="1">
+                <a:latin typeface="Menlo" panose="020B0609030804020204" pitchFamily="49" charset="0"/>
+                <a:ea typeface="Menlo" panose="020B0609030804020204" pitchFamily="49" charset="0"/>
+                <a:cs typeface="Menlo" panose="020B0609030804020204" pitchFamily="49" charset="0"/>
               </a:rPr>
               <a:t>c.name</a:t>
             </a:r>
             <a:r>
-              <a:rPr lang="en-US" sz="1000" dirty="0">
-                <a:latin typeface="Avenir Book" panose="02000503020000020003" pitchFamily="2" charset="0"/>
+              <a:rPr lang="en-US" sz="900" dirty="0">
+                <a:latin typeface="Menlo" panose="020B0609030804020204" pitchFamily="49" charset="0"/>
+                <a:ea typeface="Menlo" panose="020B0609030804020204" pitchFamily="49" charset="0"/>
+                <a:cs typeface="Menlo" panose="020B0609030804020204" pitchFamily="49" charset="0"/>
               </a:rPr>
               <a:t> AS city,</a:t>
             </a:r>
           </a:p>
           <a:p>
             <a:r>
-              <a:rPr lang="en-US" sz="1000" dirty="0" err="1">
-                <a:latin typeface="Avenir Book" panose="02000503020000020003" pitchFamily="2" charset="0"/>
+              <a:rPr lang="en-US" sz="900" dirty="0" err="1">
+                <a:latin typeface="Menlo" panose="020B0609030804020204" pitchFamily="49" charset="0"/>
+                <a:ea typeface="Menlo" panose="020B0609030804020204" pitchFamily="49" charset="0"/>
+                <a:cs typeface="Menlo" panose="020B0609030804020204" pitchFamily="49" charset="0"/>
               </a:rPr>
               <a:t>w.record_date</a:t>
             </a:r>
             <a:r>
-              <a:rPr lang="en-US" sz="1000" dirty="0">
-                <a:latin typeface="Avenir Book" panose="02000503020000020003" pitchFamily="2" charset="0"/>
+              <a:rPr lang="en-US" sz="900" dirty="0">
+                <a:latin typeface="Menlo" panose="020B0609030804020204" pitchFamily="49" charset="0"/>
+                <a:ea typeface="Menlo" panose="020B0609030804020204" pitchFamily="49" charset="0"/>
+                <a:cs typeface="Menlo" panose="020B0609030804020204" pitchFamily="49" charset="0"/>
               </a:rPr>
               <a:t>,</a:t>
             </a:r>
           </a:p>
           <a:p>
             <a:r>
-              <a:rPr lang="en-US" sz="1000" dirty="0" err="1">
-                <a:latin typeface="Avenir Book" panose="02000503020000020003" pitchFamily="2" charset="0"/>
+              <a:rPr lang="en-US" sz="900" dirty="0" err="1">
+                <a:latin typeface="Menlo" panose="020B0609030804020204" pitchFamily="49" charset="0"/>
+                <a:ea typeface="Menlo" panose="020B0609030804020204" pitchFamily="49" charset="0"/>
+                <a:cs typeface="Menlo" panose="020B0609030804020204" pitchFamily="49" charset="0"/>
               </a:rPr>
               <a:t>w.temp_max_c</a:t>
             </a:r>
             <a:r>
-              <a:rPr lang="en-US" sz="1000" dirty="0">
-                <a:latin typeface="Avenir Book" panose="02000503020000020003" pitchFamily="2" charset="0"/>
+              <a:rPr lang="en-US" sz="900" dirty="0">
+                <a:latin typeface="Menlo" panose="020B0609030804020204" pitchFamily="49" charset="0"/>
+                <a:ea typeface="Menlo" panose="020B0609030804020204" pitchFamily="49" charset="0"/>
+                <a:cs typeface="Menlo" panose="020B0609030804020204" pitchFamily="49" charset="0"/>
               </a:rPr>
               <a:t> AS “hottest max temp (</a:t>
             </a:r>
             <a:r>
-              <a:rPr lang="en-US" sz="1000" dirty="0" err="1">
-                <a:latin typeface="Avenir Book" panose="02000503020000020003" pitchFamily="2" charset="0"/>
+              <a:rPr lang="en-US" sz="900" dirty="0" err="1">
+                <a:latin typeface="Menlo" panose="020B0609030804020204" pitchFamily="49" charset="0"/>
+                <a:ea typeface="Menlo" panose="020B0609030804020204" pitchFamily="49" charset="0"/>
+                <a:cs typeface="Menlo" panose="020B0609030804020204" pitchFamily="49" charset="0"/>
               </a:rPr>
               <a:t>celsius</a:t>
             </a:r>
             <a:r>
-              <a:rPr lang="en-US" sz="1000" dirty="0">
-                <a:latin typeface="Avenir Book" panose="02000503020000020003" pitchFamily="2" charset="0"/>
+              <a:rPr lang="en-US" sz="900" dirty="0">
+                <a:latin typeface="Menlo" panose="020B0609030804020204" pitchFamily="49" charset="0"/>
+                <a:ea typeface="Menlo" panose="020B0609030804020204" pitchFamily="49" charset="0"/>
+                <a:cs typeface="Menlo" panose="020B0609030804020204" pitchFamily="49" charset="0"/>
               </a:rPr>
               <a:t>)”,</a:t>
             </a:r>
           </a:p>
           <a:p>
             <a:r>
-              <a:rPr lang="en-US" sz="1000" dirty="0">
-                <a:latin typeface="Avenir Book" panose="02000503020000020003" pitchFamily="2" charset="0"/>
+              <a:rPr lang="en-US" sz="900" dirty="0">
+                <a:latin typeface="Menlo" panose="020B0609030804020204" pitchFamily="49" charset="0"/>
+                <a:ea typeface="Menlo" panose="020B0609030804020204" pitchFamily="49" charset="0"/>
+                <a:cs typeface="Menlo" panose="020B0609030804020204" pitchFamily="49" charset="0"/>
               </a:rPr>
               <a:t>ROUND((</a:t>
             </a:r>
             <a:r>
-              <a:rPr lang="en-US" sz="1000" dirty="0" err="1">
-                <a:latin typeface="Avenir Book" panose="02000503020000020003" pitchFamily="2" charset="0"/>
+              <a:rPr lang="en-US" sz="900" dirty="0" err="1">
+                <a:latin typeface="Menlo" panose="020B0609030804020204" pitchFamily="49" charset="0"/>
+                <a:ea typeface="Menlo" panose="020B0609030804020204" pitchFamily="49" charset="0"/>
+                <a:cs typeface="Menlo" panose="020B0609030804020204" pitchFamily="49" charset="0"/>
               </a:rPr>
               <a:t>w.temp_max_c</a:t>
             </a:r>
             <a:r>
-              <a:rPr lang="en-US" sz="1000" dirty="0">
-                <a:latin typeface="Avenir Book" panose="02000503020000020003" pitchFamily="2" charset="0"/>
+              <a:rPr lang="en-US" sz="900" dirty="0">
+                <a:latin typeface="Menlo" panose="020B0609030804020204" pitchFamily="49" charset="0"/>
+                <a:ea typeface="Menlo" panose="020B0609030804020204" pitchFamily="49" charset="0"/>
+                <a:cs typeface="Menlo" panose="020B0609030804020204" pitchFamily="49" charset="0"/>
               </a:rPr>
               <a:t> * 9.0 / 5.0) + 32, 2) </a:t>
             </a:r>
           </a:p>
           <a:p>
             <a:r>
-              <a:rPr lang="en-US" sz="1000" dirty="0">
-                <a:latin typeface="Avenir Book" panose="02000503020000020003" pitchFamily="2" charset="0"/>
+              <a:rPr lang="en-US" sz="900" dirty="0">
+                <a:latin typeface="Menlo" panose="020B0609030804020204" pitchFamily="49" charset="0"/>
+                <a:ea typeface="Menlo" panose="020B0609030804020204" pitchFamily="49" charset="0"/>
+                <a:cs typeface="Menlo" panose="020B0609030804020204" pitchFamily="49" charset="0"/>
               </a:rPr>
               <a:t>AS “hottest max temp (</a:t>
             </a:r>
             <a:r>
-              <a:rPr lang="en-US" sz="1000" dirty="0" err="1">
-                <a:latin typeface="Avenir Book" panose="02000503020000020003" pitchFamily="2" charset="0"/>
+              <a:rPr lang="en-US" sz="900" dirty="0" err="1">
+                <a:latin typeface="Menlo" panose="020B0609030804020204" pitchFamily="49" charset="0"/>
+                <a:ea typeface="Menlo" panose="020B0609030804020204" pitchFamily="49" charset="0"/>
+                <a:cs typeface="Menlo" panose="020B0609030804020204" pitchFamily="49" charset="0"/>
               </a:rPr>
               <a:t>fahrenheit</a:t>
             </a:r>
             <a:r>
-              <a:rPr lang="en-US" sz="1000" dirty="0">
-                <a:latin typeface="Avenir Book" panose="02000503020000020003" pitchFamily="2" charset="0"/>
+              <a:rPr lang="en-US" sz="900" dirty="0">
+                <a:latin typeface="Menlo" panose="020B0609030804020204" pitchFamily="49" charset="0"/>
+                <a:ea typeface="Menlo" panose="020B0609030804020204" pitchFamily="49" charset="0"/>
+                <a:cs typeface="Menlo" panose="020B0609030804020204" pitchFamily="49" charset="0"/>
               </a:rPr>
               <a:t>)”</a:t>
             </a:r>
           </a:p>
           <a:p>
             <a:r>
-              <a:rPr lang="en-US" sz="1000" dirty="0">
-                <a:latin typeface="Avenir Book" panose="02000503020000020003" pitchFamily="2" charset="0"/>
+              <a:rPr lang="en-US" sz="900" dirty="0">
+                <a:latin typeface="Menlo" panose="020B0609030804020204" pitchFamily="49" charset="0"/>
+                <a:ea typeface="Menlo" panose="020B0609030804020204" pitchFamily="49" charset="0"/>
+                <a:cs typeface="Menlo" panose="020B0609030804020204" pitchFamily="49" charset="0"/>
               </a:rPr>
               <a:t>FROM weather w</a:t>
             </a:r>
           </a:p>
           <a:p>
             <a:r>
-              <a:rPr lang="en-US" sz="1000" dirty="0">
-                <a:latin typeface="Avenir Book" panose="02000503020000020003" pitchFamily="2" charset="0"/>
+              <a:rPr lang="en-US" sz="900" dirty="0">
+                <a:latin typeface="Menlo" panose="020B0609030804020204" pitchFamily="49" charset="0"/>
+                <a:ea typeface="Menlo" panose="020B0609030804020204" pitchFamily="49" charset="0"/>
+                <a:cs typeface="Menlo" panose="020B0609030804020204" pitchFamily="49" charset="0"/>
               </a:rPr>
               <a:t>JOIN cities c ON </a:t>
             </a:r>
             <a:r>
-              <a:rPr lang="en-US" sz="1000" dirty="0" err="1">
-                <a:latin typeface="Avenir Book" panose="02000503020000020003" pitchFamily="2" charset="0"/>
+              <a:rPr lang="en-US" sz="900" dirty="0" err="1">
+                <a:latin typeface="Menlo" panose="020B0609030804020204" pitchFamily="49" charset="0"/>
+                <a:ea typeface="Menlo" panose="020B0609030804020204" pitchFamily="49" charset="0"/>
+                <a:cs typeface="Menlo" panose="020B0609030804020204" pitchFamily="49" charset="0"/>
               </a:rPr>
               <a:t>c.city_id</a:t>
             </a:r>
             <a:r>
-              <a:rPr lang="en-US" sz="1000" dirty="0">
-                <a:latin typeface="Avenir Book" panose="02000503020000020003" pitchFamily="2" charset="0"/>
+              <a:rPr lang="en-US" sz="900" dirty="0">
+                <a:latin typeface="Menlo" panose="020B0609030804020204" pitchFamily="49" charset="0"/>
+                <a:ea typeface="Menlo" panose="020B0609030804020204" pitchFamily="49" charset="0"/>
+                <a:cs typeface="Menlo" panose="020B0609030804020204" pitchFamily="49" charset="0"/>
               </a:rPr>
               <a:t> = </a:t>
             </a:r>
             <a:r>
-              <a:rPr lang="en-US" sz="1000" dirty="0" err="1">
-                <a:latin typeface="Avenir Book" panose="02000503020000020003" pitchFamily="2" charset="0"/>
+              <a:rPr lang="en-US" sz="900" dirty="0" err="1">
+                <a:latin typeface="Menlo" panose="020B0609030804020204" pitchFamily="49" charset="0"/>
+                <a:ea typeface="Menlo" panose="020B0609030804020204" pitchFamily="49" charset="0"/>
+                <a:cs typeface="Menlo" panose="020B0609030804020204" pitchFamily="49" charset="0"/>
               </a:rPr>
               <a:t>w.city_id</a:t>
             </a:r>
-            <a:endParaRPr lang="en-US" sz="1000" dirty="0">
-              <a:latin typeface="Avenir Book" panose="02000503020000020003" pitchFamily="2" charset="0"/>
+            <a:endParaRPr lang="en-US" sz="900" dirty="0">
+              <a:latin typeface="Menlo" panose="020B0609030804020204" pitchFamily="49" charset="0"/>
+              <a:ea typeface="Menlo" panose="020B0609030804020204" pitchFamily="49" charset="0"/>
+              <a:cs typeface="Menlo" panose="020B0609030804020204" pitchFamily="49" charset="0"/>
             </a:endParaRPr>
           </a:p>
           <a:p>
             <a:r>
-              <a:rPr lang="en-US" sz="1000" dirty="0">
-                <a:latin typeface="Avenir Book" panose="02000503020000020003" pitchFamily="2" charset="0"/>
+              <a:rPr lang="en-US" sz="900" dirty="0">
+                <a:latin typeface="Menlo" panose="020B0609030804020204" pitchFamily="49" charset="0"/>
+                <a:ea typeface="Menlo" panose="020B0609030804020204" pitchFamily="49" charset="0"/>
+                <a:cs typeface="Menlo" panose="020B0609030804020204" pitchFamily="49" charset="0"/>
               </a:rPr>
               <a:t>ORDER BY </a:t>
             </a:r>
             <a:r>
-              <a:rPr lang="en-US" sz="1000" dirty="0" err="1">
-                <a:latin typeface="Avenir Book" panose="02000503020000020003" pitchFamily="2" charset="0"/>
+              <a:rPr lang="en-US" sz="900" dirty="0" err="1">
+                <a:latin typeface="Menlo" panose="020B0609030804020204" pitchFamily="49" charset="0"/>
+                <a:ea typeface="Menlo" panose="020B0609030804020204" pitchFamily="49" charset="0"/>
+                <a:cs typeface="Menlo" panose="020B0609030804020204" pitchFamily="49" charset="0"/>
               </a:rPr>
               <a:t>c.city_id</a:t>
             </a:r>
             <a:r>
-              <a:rPr lang="en-US" sz="1000" dirty="0">
-                <a:latin typeface="Avenir Book" panose="02000503020000020003" pitchFamily="2" charset="0"/>
+              <a:rPr lang="en-US" sz="900" dirty="0">
+                <a:latin typeface="Menlo" panose="020B0609030804020204" pitchFamily="49" charset="0"/>
+                <a:ea typeface="Menlo" panose="020B0609030804020204" pitchFamily="49" charset="0"/>
+                <a:cs typeface="Menlo" panose="020B0609030804020204" pitchFamily="49" charset="0"/>
               </a:rPr>
               <a:t>, </a:t>
             </a:r>
             <a:r>
-              <a:rPr lang="en-US" sz="1000" dirty="0" err="1">
-                <a:latin typeface="Avenir Book" panose="02000503020000020003" pitchFamily="2" charset="0"/>
+              <a:rPr lang="en-US" sz="900" dirty="0" err="1">
+                <a:latin typeface="Menlo" panose="020B0609030804020204" pitchFamily="49" charset="0"/>
+                <a:ea typeface="Menlo" panose="020B0609030804020204" pitchFamily="49" charset="0"/>
+                <a:cs typeface="Menlo" panose="020B0609030804020204" pitchFamily="49" charset="0"/>
               </a:rPr>
               <a:t>w.temp_max_c</a:t>
             </a:r>
             <a:r>
-              <a:rPr lang="en-US" sz="1000" dirty="0">
-                <a:latin typeface="Avenir Book" panose="02000503020000020003" pitchFamily="2" charset="0"/>
+              <a:rPr lang="en-US" sz="900" dirty="0">
+                <a:latin typeface="Menlo" panose="020B0609030804020204" pitchFamily="49" charset="0"/>
+                <a:ea typeface="Menlo" panose="020B0609030804020204" pitchFamily="49" charset="0"/>
+                <a:cs typeface="Menlo" panose="020B0609030804020204" pitchFamily="49" charset="0"/>
               </a:rPr>
               <a:t> DESC, </a:t>
             </a:r>
             <a:r>
-              <a:rPr lang="en-US" sz="1000" dirty="0" err="1">
-                <a:latin typeface="Avenir Book" panose="02000503020000020003" pitchFamily="2" charset="0"/>
+              <a:rPr lang="en-US" sz="900" dirty="0" err="1">
+                <a:latin typeface="Menlo" panose="020B0609030804020204" pitchFamily="49" charset="0"/>
+                <a:ea typeface="Menlo" panose="020B0609030804020204" pitchFamily="49" charset="0"/>
+                <a:cs typeface="Menlo" panose="020B0609030804020204" pitchFamily="49" charset="0"/>
               </a:rPr>
               <a:t>w.record_date</a:t>
             </a:r>
             <a:r>
-              <a:rPr lang="en-US" sz="1000" dirty="0">
-                <a:latin typeface="Avenir Book" panose="02000503020000020003" pitchFamily="2" charset="0"/>
+              <a:rPr lang="en-US" sz="900" dirty="0">
+                <a:latin typeface="Menlo" panose="020B0609030804020204" pitchFamily="49" charset="0"/>
+                <a:ea typeface="Menlo" panose="020B0609030804020204" pitchFamily="49" charset="0"/>
+                <a:cs typeface="Menlo" panose="020B0609030804020204" pitchFamily="49" charset="0"/>
               </a:rPr>
               <a:t>;</a:t>
             </a:r>
@@ -5460,6 +5522,8 @@
                 </a:solidFill>
                 <a:effectLst/>
                 <a:latin typeface="Menlo" panose="020B0609030804020204" pitchFamily="49" charset="0"/>
+                <a:ea typeface="Menlo" panose="020B0609030804020204" pitchFamily="49" charset="0"/>
+                <a:cs typeface="Menlo" panose="020B0609030804020204" pitchFamily="49" charset="0"/>
               </a:rPr>
             </a:br>
             <a:endParaRPr lang="en-US" sz="900" b="0" dirty="0">
@@ -5468,6 +5532,8 @@
               </a:solidFill>
               <a:effectLst/>
               <a:latin typeface="Menlo" panose="020B0609030804020204" pitchFamily="49" charset="0"/>
+              <a:ea typeface="Menlo" panose="020B0609030804020204" pitchFamily="49" charset="0"/>
+              <a:cs typeface="Menlo" panose="020B0609030804020204" pitchFamily="49" charset="0"/>
             </a:endParaRPr>
           </a:p>
           <a:p>
@@ -5481,6 +5547,8 @@
               <a:rPr lang="en-US" sz="900" b="1" dirty="0">
                 <a:effectLst/>
                 <a:latin typeface="Menlo" panose="020B0609030804020204" pitchFamily="49" charset="0"/>
+                <a:ea typeface="Menlo" panose="020B0609030804020204" pitchFamily="49" charset="0"/>
+                <a:cs typeface="Menlo" panose="020B0609030804020204" pitchFamily="49" charset="0"/>
               </a:rPr>
               <a:t>-- Determine average rainfall per city</a:t>
             </a:r>
@@ -5496,6 +5564,8 @@
               <a:rPr lang="en-US" sz="900" b="0" dirty="0">
                 <a:effectLst/>
                 <a:latin typeface="Menlo" panose="020B0609030804020204" pitchFamily="49" charset="0"/>
+                <a:ea typeface="Menlo" panose="020B0609030804020204" pitchFamily="49" charset="0"/>
+                <a:cs typeface="Menlo" panose="020B0609030804020204" pitchFamily="49" charset="0"/>
               </a:rPr>
               <a:t>SELECT</a:t>
             </a:r>
@@ -5511,6 +5581,8 @@
               <a:rPr lang="en-US" sz="900" b="0" dirty="0" err="1">
                 <a:effectLst/>
                 <a:latin typeface="Menlo" panose="020B0609030804020204" pitchFamily="49" charset="0"/>
+                <a:ea typeface="Menlo" panose="020B0609030804020204" pitchFamily="49" charset="0"/>
+                <a:cs typeface="Menlo" panose="020B0609030804020204" pitchFamily="49" charset="0"/>
               </a:rPr>
               <a:t>c.name</a:t>
             </a:r>
@@ -5518,6 +5590,8 @@
               <a:rPr lang="en-US" sz="900" b="0" dirty="0">
                 <a:effectLst/>
                 <a:latin typeface="Menlo" panose="020B0609030804020204" pitchFamily="49" charset="0"/>
+                <a:ea typeface="Menlo" panose="020B0609030804020204" pitchFamily="49" charset="0"/>
+                <a:cs typeface="Menlo" panose="020B0609030804020204" pitchFamily="49" charset="0"/>
               </a:rPr>
               <a:t> AS city,</a:t>
             </a:r>
@@ -5533,6 +5607,8 @@
               <a:rPr lang="en-US" sz="900" b="0" dirty="0">
                 <a:effectLst/>
                 <a:latin typeface="Menlo" panose="020B0609030804020204" pitchFamily="49" charset="0"/>
+                <a:ea typeface="Menlo" panose="020B0609030804020204" pitchFamily="49" charset="0"/>
+                <a:cs typeface="Menlo" panose="020B0609030804020204" pitchFamily="49" charset="0"/>
               </a:rPr>
               <a:t>ROUND(AVG(</a:t>
             </a:r>
@@ -5540,6 +5616,8 @@
               <a:rPr lang="en-US" sz="900" b="0" dirty="0" err="1">
                 <a:effectLst/>
                 <a:latin typeface="Menlo" panose="020B0609030804020204" pitchFamily="49" charset="0"/>
+                <a:ea typeface="Menlo" panose="020B0609030804020204" pitchFamily="49" charset="0"/>
+                <a:cs typeface="Menlo" panose="020B0609030804020204" pitchFamily="49" charset="0"/>
               </a:rPr>
               <a:t>w.rain_mm</a:t>
             </a:r>
@@ -5547,6 +5625,8 @@
               <a:rPr lang="en-US" sz="900" b="0" dirty="0">
                 <a:effectLst/>
                 <a:latin typeface="Menlo" panose="020B0609030804020204" pitchFamily="49" charset="0"/>
+                <a:ea typeface="Menlo" panose="020B0609030804020204" pitchFamily="49" charset="0"/>
+                <a:cs typeface="Menlo" panose="020B0609030804020204" pitchFamily="49" charset="0"/>
               </a:rPr>
               <a:t>), 2) AS </a:t>
             </a:r>
@@ -5554,6 +5634,8 @@
               <a:rPr lang="en-US" sz="900" b="0" dirty="0" err="1">
                 <a:effectLst/>
                 <a:latin typeface="Menlo" panose="020B0609030804020204" pitchFamily="49" charset="0"/>
+                <a:ea typeface="Menlo" panose="020B0609030804020204" pitchFamily="49" charset="0"/>
+                <a:cs typeface="Menlo" panose="020B0609030804020204" pitchFamily="49" charset="0"/>
               </a:rPr>
               <a:t>average_rain</a:t>
             </a:r>
@@ -5561,6 +5643,8 @@
               <a:rPr lang="en-US" sz="900" b="0" dirty="0">
                 <a:effectLst/>
                 <a:latin typeface="Menlo" panose="020B0609030804020204" pitchFamily="49" charset="0"/>
+                <a:ea typeface="Menlo" panose="020B0609030804020204" pitchFamily="49" charset="0"/>
+                <a:cs typeface="Menlo" panose="020B0609030804020204" pitchFamily="49" charset="0"/>
               </a:rPr>
               <a:t>,</a:t>
             </a:r>
@@ -5576,6 +5660,8 @@
               <a:rPr lang="en-US" sz="900" b="0" dirty="0">
                 <a:effectLst/>
                 <a:latin typeface="Menlo" panose="020B0609030804020204" pitchFamily="49" charset="0"/>
+                <a:ea typeface="Menlo" panose="020B0609030804020204" pitchFamily="49" charset="0"/>
+                <a:cs typeface="Menlo" panose="020B0609030804020204" pitchFamily="49" charset="0"/>
               </a:rPr>
               <a:t>ROUND(SUM(</a:t>
             </a:r>
@@ -5583,6 +5669,8 @@
               <a:rPr lang="en-US" sz="900" b="0" dirty="0" err="1">
                 <a:effectLst/>
                 <a:latin typeface="Menlo" panose="020B0609030804020204" pitchFamily="49" charset="0"/>
+                <a:ea typeface="Menlo" panose="020B0609030804020204" pitchFamily="49" charset="0"/>
+                <a:cs typeface="Menlo" panose="020B0609030804020204" pitchFamily="49" charset="0"/>
               </a:rPr>
               <a:t>w.rain_mm</a:t>
             </a:r>
@@ -5590,6 +5678,8 @@
               <a:rPr lang="en-US" sz="900" b="0" dirty="0">
                 <a:effectLst/>
                 <a:latin typeface="Menlo" panose="020B0609030804020204" pitchFamily="49" charset="0"/>
+                <a:ea typeface="Menlo" panose="020B0609030804020204" pitchFamily="49" charset="0"/>
+                <a:cs typeface="Menlo" panose="020B0609030804020204" pitchFamily="49" charset="0"/>
               </a:rPr>
               <a:t>), 2) AS </a:t>
             </a:r>
@@ -5597,12 +5687,16 @@
               <a:rPr lang="en-US" sz="900" b="0" dirty="0" err="1">
                 <a:effectLst/>
                 <a:latin typeface="Menlo" panose="020B0609030804020204" pitchFamily="49" charset="0"/>
+                <a:ea typeface="Menlo" panose="020B0609030804020204" pitchFamily="49" charset="0"/>
+                <a:cs typeface="Menlo" panose="020B0609030804020204" pitchFamily="49" charset="0"/>
               </a:rPr>
               <a:t>total_rain</a:t>
             </a:r>
             <a:endParaRPr lang="en-US" sz="900" b="0" dirty="0">
               <a:effectLst/>
               <a:latin typeface="Menlo" panose="020B0609030804020204" pitchFamily="49" charset="0"/>
+              <a:ea typeface="Menlo" panose="020B0609030804020204" pitchFamily="49" charset="0"/>
+              <a:cs typeface="Menlo" panose="020B0609030804020204" pitchFamily="49" charset="0"/>
             </a:endParaRPr>
           </a:p>
           <a:p>
@@ -5616,6 +5710,8 @@
               <a:rPr lang="en-US" sz="900" b="0" dirty="0">
                 <a:effectLst/>
                 <a:latin typeface="Menlo" panose="020B0609030804020204" pitchFamily="49" charset="0"/>
+                <a:ea typeface="Menlo" panose="020B0609030804020204" pitchFamily="49" charset="0"/>
+                <a:cs typeface="Menlo" panose="020B0609030804020204" pitchFamily="49" charset="0"/>
               </a:rPr>
               <a:t>FROM weather w</a:t>
             </a:r>
@@ -5631,6 +5727,8 @@
               <a:rPr lang="en-US" sz="900" b="0" dirty="0">
                 <a:effectLst/>
                 <a:latin typeface="Menlo" panose="020B0609030804020204" pitchFamily="49" charset="0"/>
+                <a:ea typeface="Menlo" panose="020B0609030804020204" pitchFamily="49" charset="0"/>
+                <a:cs typeface="Menlo" panose="020B0609030804020204" pitchFamily="49" charset="0"/>
               </a:rPr>
               <a:t>JOIN cities c ON </a:t>
             </a:r>
@@ -5638,6 +5736,8 @@
               <a:rPr lang="en-US" sz="900" b="0" dirty="0" err="1">
                 <a:effectLst/>
                 <a:latin typeface="Menlo" panose="020B0609030804020204" pitchFamily="49" charset="0"/>
+                <a:ea typeface="Menlo" panose="020B0609030804020204" pitchFamily="49" charset="0"/>
+                <a:cs typeface="Menlo" panose="020B0609030804020204" pitchFamily="49" charset="0"/>
               </a:rPr>
               <a:t>c.city_id</a:t>
             </a:r>
@@ -5645,6 +5745,8 @@
               <a:rPr lang="en-US" sz="900" b="0" dirty="0">
                 <a:effectLst/>
                 <a:latin typeface="Menlo" panose="020B0609030804020204" pitchFamily="49" charset="0"/>
+                <a:ea typeface="Menlo" panose="020B0609030804020204" pitchFamily="49" charset="0"/>
+                <a:cs typeface="Menlo" panose="020B0609030804020204" pitchFamily="49" charset="0"/>
               </a:rPr>
               <a:t> = </a:t>
             </a:r>
@@ -5652,12 +5754,16 @@
               <a:rPr lang="en-US" sz="900" b="0" dirty="0" err="1">
                 <a:effectLst/>
                 <a:latin typeface="Menlo" panose="020B0609030804020204" pitchFamily="49" charset="0"/>
+                <a:ea typeface="Menlo" panose="020B0609030804020204" pitchFamily="49" charset="0"/>
+                <a:cs typeface="Menlo" panose="020B0609030804020204" pitchFamily="49" charset="0"/>
               </a:rPr>
               <a:t>w.city_id</a:t>
             </a:r>
             <a:endParaRPr lang="en-US" sz="900" b="0" dirty="0">
               <a:effectLst/>
               <a:latin typeface="Menlo" panose="020B0609030804020204" pitchFamily="49" charset="0"/>
+              <a:ea typeface="Menlo" panose="020B0609030804020204" pitchFamily="49" charset="0"/>
+              <a:cs typeface="Menlo" panose="020B0609030804020204" pitchFamily="49" charset="0"/>
             </a:endParaRPr>
           </a:p>
           <a:p>
@@ -5671,6 +5777,8 @@
               <a:rPr lang="en-US" sz="900" b="0" dirty="0">
                 <a:effectLst/>
                 <a:latin typeface="Menlo" panose="020B0609030804020204" pitchFamily="49" charset="0"/>
+                <a:ea typeface="Menlo" panose="020B0609030804020204" pitchFamily="49" charset="0"/>
+                <a:cs typeface="Menlo" panose="020B0609030804020204" pitchFamily="49" charset="0"/>
               </a:rPr>
               <a:t>GROUP BY </a:t>
             </a:r>
@@ -5678,12 +5786,16 @@
               <a:rPr lang="en-US" sz="900" b="0" dirty="0" err="1">
                 <a:effectLst/>
                 <a:latin typeface="Menlo" panose="020B0609030804020204" pitchFamily="49" charset="0"/>
+                <a:ea typeface="Menlo" panose="020B0609030804020204" pitchFamily="49" charset="0"/>
+                <a:cs typeface="Menlo" panose="020B0609030804020204" pitchFamily="49" charset="0"/>
               </a:rPr>
               <a:t>c.name</a:t>
             </a:r>
             <a:endParaRPr lang="en-US" sz="900" b="0" dirty="0">
               <a:effectLst/>
               <a:latin typeface="Menlo" panose="020B0609030804020204" pitchFamily="49" charset="0"/>
+              <a:ea typeface="Menlo" panose="020B0609030804020204" pitchFamily="49" charset="0"/>
+              <a:cs typeface="Menlo" panose="020B0609030804020204" pitchFamily="49" charset="0"/>
             </a:endParaRPr>
           </a:p>
           <a:p>
@@ -5697,6 +5809,8 @@
               <a:rPr lang="en-US" sz="900" b="0" dirty="0">
                 <a:effectLst/>
                 <a:latin typeface="Menlo" panose="020B0609030804020204" pitchFamily="49" charset="0"/>
+                <a:ea typeface="Menlo" panose="020B0609030804020204" pitchFamily="49" charset="0"/>
+                <a:cs typeface="Menlo" panose="020B0609030804020204" pitchFamily="49" charset="0"/>
               </a:rPr>
               <a:t>ORDER BY </a:t>
             </a:r>
@@ -5704,6 +5818,8 @@
               <a:rPr lang="en-US" sz="900" b="0" dirty="0" err="1">
                 <a:effectLst/>
                 <a:latin typeface="Menlo" panose="020B0609030804020204" pitchFamily="49" charset="0"/>
+                <a:ea typeface="Menlo" panose="020B0609030804020204" pitchFamily="49" charset="0"/>
+                <a:cs typeface="Menlo" panose="020B0609030804020204" pitchFamily="49" charset="0"/>
               </a:rPr>
               <a:t>average_rain</a:t>
             </a:r>
@@ -5711,6 +5827,8 @@
               <a:rPr lang="en-US" sz="900" b="0" dirty="0">
                 <a:effectLst/>
                 <a:latin typeface="Menlo" panose="020B0609030804020204" pitchFamily="49" charset="0"/>
+                <a:ea typeface="Menlo" panose="020B0609030804020204" pitchFamily="49" charset="0"/>
+                <a:cs typeface="Menlo" panose="020B0609030804020204" pitchFamily="49" charset="0"/>
               </a:rPr>
               <a:t> DESC;</a:t>
             </a:r>
@@ -6387,7 +6505,7 @@
         <p:spPr>
           <a:xfrm>
             <a:off x="7756276" y="2246980"/>
-            <a:ext cx="4194587" cy="2792944"/>
+            <a:ext cx="4194587" cy="3481531"/>
           </a:xfrm>
           <a:prstGeom prst="rect">
             <a:avLst/>
@@ -6402,13 +6520,14 @@
           <a:p>
             <a:r>
               <a:rPr lang="en-US" sz="900" b="1" dirty="0">
-                <a:effectLst/>
-                <a:latin typeface="Menlo" panose="020B0609030804020204" pitchFamily="49" charset="0"/>
-                <a:ea typeface="Menlo" panose="020B0609030804020204" pitchFamily="49" charset="0"/>
-                <a:cs typeface="Menlo" panose="020B0609030804020204" pitchFamily="49" charset="0"/>
-              </a:rPr>
-              <a:t>-- Query 5: Determine frequency of extreme heat days (max </a:t>
-            </a:r>
+                <a:latin typeface="Menlo" panose="020B0609030804020204" pitchFamily="49" charset="0"/>
+                <a:ea typeface="Menlo" panose="020B0609030804020204" pitchFamily="49" charset="0"/>
+                <a:cs typeface="Menlo" panose="020B0609030804020204" pitchFamily="49" charset="0"/>
+              </a:rPr>
+              <a:t>-- Query 5: Determine frequency of extreme heat days (max temp &gt;= 86°C)</a:t>
+            </a:r>
+          </a:p>
+          <a:p>
             <a:r>
               <a:rPr lang="en-US" sz="900" dirty="0">
                 <a:latin typeface="Menlo" panose="020B0609030804020204" pitchFamily="49" charset="0"/>
@@ -6577,52 +6696,17 @@
                 <a:ea typeface="Menlo" panose="020B0609030804020204" pitchFamily="49" charset="0"/>
                 <a:cs typeface="Menlo" panose="020B0609030804020204" pitchFamily="49" charset="0"/>
               </a:rPr>
-              <a:t>) AS “percentage of hot days”</a:t>
-            </a:r>
-          </a:p>
-          <a:p>
-            <a:r>
+              <a:t>) AS "Percentage of hot days"</a:t>
+            </a:r>
+          </a:p>
+          <a:p>
+            <a:br>
               <a:rPr lang="en-US" sz="900" dirty="0">
                 <a:latin typeface="Menlo" panose="020B0609030804020204" pitchFamily="49" charset="0"/>
                 <a:ea typeface="Menlo" panose="020B0609030804020204" pitchFamily="49" charset="0"/>
                 <a:cs typeface="Menlo" panose="020B0609030804020204" pitchFamily="49" charset="0"/>
               </a:rPr>
-              <a:t>FROM weather w</a:t>
-            </a:r>
-          </a:p>
-          <a:p>
-            <a:r>
-              <a:rPr lang="en-US" sz="900" dirty="0">
-                <a:latin typeface="Menlo" panose="020B0609030804020204" pitchFamily="49" charset="0"/>
-                <a:ea typeface="Menlo" panose="020B0609030804020204" pitchFamily="49" charset="0"/>
-                <a:cs typeface="Menlo" panose="020B0609030804020204" pitchFamily="49" charset="0"/>
-              </a:rPr>
-              <a:t>JOIN cities c ON </a:t>
-            </a:r>
-            <a:r>
-              <a:rPr lang="en-US" sz="900" dirty="0" err="1">
-                <a:latin typeface="Menlo" panose="020B0609030804020204" pitchFamily="49" charset="0"/>
-                <a:ea typeface="Menlo" panose="020B0609030804020204" pitchFamily="49" charset="0"/>
-                <a:cs typeface="Menlo" panose="020B0609030804020204" pitchFamily="49" charset="0"/>
-              </a:rPr>
-              <a:t>c.city_id</a:t>
-            </a:r>
-            <a:r>
-              <a:rPr lang="en-US" sz="900" dirty="0">
-                <a:latin typeface="Menlo" panose="020B0609030804020204" pitchFamily="49" charset="0"/>
-                <a:ea typeface="Menlo" panose="020B0609030804020204" pitchFamily="49" charset="0"/>
-                <a:cs typeface="Menlo" panose="020B0609030804020204" pitchFamily="49" charset="0"/>
-              </a:rPr>
-              <a:t> = </a:t>
-            </a:r>
-            <a:r>
-              <a:rPr lang="en-US" sz="900" dirty="0" err="1">
-                <a:latin typeface="Menlo" panose="020B0609030804020204" pitchFamily="49" charset="0"/>
-                <a:ea typeface="Menlo" panose="020B0609030804020204" pitchFamily="49" charset="0"/>
-                <a:cs typeface="Menlo" panose="020B0609030804020204" pitchFamily="49" charset="0"/>
-              </a:rPr>
-              <a:t>w.city_id</a:t>
-            </a:r>
+            </a:br>
             <a:endParaRPr lang="en-US" sz="900" dirty="0">
               <a:latin typeface="Menlo" panose="020B0609030804020204" pitchFamily="49" charset="0"/>
               <a:ea typeface="Menlo" panose="020B0609030804020204" pitchFamily="49" charset="0"/>
@@ -6636,7 +6720,17 @@
                 <a:ea typeface="Menlo" panose="020B0609030804020204" pitchFamily="49" charset="0"/>
                 <a:cs typeface="Menlo" panose="020B0609030804020204" pitchFamily="49" charset="0"/>
               </a:rPr>
-              <a:t>GROUP BY </a:t>
+              <a:t>FROM weather w</a:t>
+            </a:r>
+          </a:p>
+          <a:p>
+            <a:r>
+              <a:rPr lang="en-US" sz="900" dirty="0">
+                <a:latin typeface="Menlo" panose="020B0609030804020204" pitchFamily="49" charset="0"/>
+                <a:ea typeface="Menlo" panose="020B0609030804020204" pitchFamily="49" charset="0"/>
+                <a:cs typeface="Menlo" panose="020B0609030804020204" pitchFamily="49" charset="0"/>
+              </a:rPr>
+              <a:t>JOIN cities c ON </a:t>
             </a:r>
             <a:r>
               <a:rPr lang="en-US" sz="900" dirty="0" err="1">
@@ -6644,7 +6738,23 @@
                 <a:ea typeface="Menlo" panose="020B0609030804020204" pitchFamily="49" charset="0"/>
                 <a:cs typeface="Menlo" panose="020B0609030804020204" pitchFamily="49" charset="0"/>
               </a:rPr>
-              <a:t>c.name</a:t>
+              <a:t>c.city_id</a:t>
+            </a:r>
+            <a:r>
+              <a:rPr lang="en-US" sz="900" dirty="0">
+                <a:latin typeface="Menlo" panose="020B0609030804020204" pitchFamily="49" charset="0"/>
+                <a:ea typeface="Menlo" panose="020B0609030804020204" pitchFamily="49" charset="0"/>
+                <a:cs typeface="Menlo" panose="020B0609030804020204" pitchFamily="49" charset="0"/>
+              </a:rPr>
+              <a:t> = </a:t>
+            </a:r>
+            <a:r>
+              <a:rPr lang="en-US" sz="900" dirty="0" err="1">
+                <a:latin typeface="Menlo" panose="020B0609030804020204" pitchFamily="49" charset="0"/>
+                <a:ea typeface="Menlo" panose="020B0609030804020204" pitchFamily="49" charset="0"/>
+                <a:cs typeface="Menlo" panose="020B0609030804020204" pitchFamily="49" charset="0"/>
+              </a:rPr>
+              <a:t>w.city_id</a:t>
             </a:r>
             <a:endParaRPr lang="en-US" sz="900" dirty="0">
               <a:latin typeface="Menlo" panose="020B0609030804020204" pitchFamily="49" charset="0"/>
@@ -6659,6 +6769,29 @@
                 <a:ea typeface="Menlo" panose="020B0609030804020204" pitchFamily="49" charset="0"/>
                 <a:cs typeface="Menlo" panose="020B0609030804020204" pitchFamily="49" charset="0"/>
               </a:rPr>
+              <a:t>GROUP BY </a:t>
+            </a:r>
+            <a:r>
+              <a:rPr lang="en-US" sz="900" dirty="0" err="1">
+                <a:latin typeface="Menlo" panose="020B0609030804020204" pitchFamily="49" charset="0"/>
+                <a:ea typeface="Menlo" panose="020B0609030804020204" pitchFamily="49" charset="0"/>
+                <a:cs typeface="Menlo" panose="020B0609030804020204" pitchFamily="49" charset="0"/>
+              </a:rPr>
+              <a:t>c.name</a:t>
+            </a:r>
+            <a:endParaRPr lang="en-US" sz="900" dirty="0">
+              <a:latin typeface="Menlo" panose="020B0609030804020204" pitchFamily="49" charset="0"/>
+              <a:ea typeface="Menlo" panose="020B0609030804020204" pitchFamily="49" charset="0"/>
+              <a:cs typeface="Menlo" panose="020B0609030804020204" pitchFamily="49" charset="0"/>
+            </a:endParaRPr>
+          </a:p>
+          <a:p>
+            <a:r>
+              <a:rPr lang="en-US" sz="900" dirty="0">
+                <a:latin typeface="Menlo" panose="020B0609030804020204" pitchFamily="49" charset="0"/>
+                <a:ea typeface="Menlo" panose="020B0609030804020204" pitchFamily="49" charset="0"/>
+                <a:cs typeface="Menlo" panose="020B0609030804020204" pitchFamily="49" charset="0"/>
+              </a:rPr>
               <a:t>ORDER BY </a:t>
             </a:r>
             <a:r>
@@ -6677,6 +6810,20 @@
               </a:rPr>
               <a:t> DESC;</a:t>
             </a:r>
+          </a:p>
+          <a:p>
+            <a:br>
+              <a:rPr lang="en-US" sz="900" dirty="0">
+                <a:latin typeface="Menlo" panose="020B0609030804020204" pitchFamily="49" charset="0"/>
+                <a:ea typeface="Menlo" panose="020B0609030804020204" pitchFamily="49" charset="0"/>
+                <a:cs typeface="Menlo" panose="020B0609030804020204" pitchFamily="49" charset="0"/>
+              </a:rPr>
+            </a:br>
+            <a:endParaRPr lang="en-US" sz="900" dirty="0">
+              <a:latin typeface="Menlo" panose="020B0609030804020204" pitchFamily="49" charset="0"/>
+              <a:ea typeface="Menlo" panose="020B0609030804020204" pitchFamily="49" charset="0"/>
+              <a:cs typeface="Menlo" panose="020B0609030804020204" pitchFamily="49" charset="0"/>
+            </a:endParaRPr>
           </a:p>
           <a:p>
             <a:pPr>
@@ -6689,9 +6836,15 @@
               <a:rPr lang="en-US" sz="900" b="0" dirty="0">
                 <a:effectLst/>
                 <a:latin typeface="Menlo" panose="020B0609030804020204" pitchFamily="49" charset="0"/>
+                <a:ea typeface="Menlo" panose="020B0609030804020204" pitchFamily="49" charset="0"/>
+                <a:cs typeface="Menlo" panose="020B0609030804020204" pitchFamily="49" charset="0"/>
               </a:rPr>
             </a:br>
-            <a:endParaRPr lang="en-US" sz="900" dirty="0"/>
+            <a:endParaRPr lang="en-US" sz="900" dirty="0">
+              <a:latin typeface="Menlo" panose="020B0609030804020204" pitchFamily="49" charset="0"/>
+              <a:ea typeface="Menlo" panose="020B0609030804020204" pitchFamily="49" charset="0"/>
+              <a:cs typeface="Menlo" panose="020B0609030804020204" pitchFamily="49" charset="0"/>
+            </a:endParaRPr>
           </a:p>
         </p:txBody>
       </p:sp>

</xml_diff>